<commit_message>
style: doi font sang Arial va Roboto Mono, bot khoang trong trong khoi code
Mo file tren Google Slides moi thay hai van de: Calibri va Consolas khong co
trong Slides nen bi thay bang font khac, va khoi code thua mot khoang trong
lon o day vi cong thuc tinh chieu cao dat qua rong.

Doi sang Arial cho phan chu va Roboto Mono cho phan code, hai font Slides co san.
Siet lai he so dong cua khoi code va khung ghi chu.

Slide day nhat gio dung 6.51 inch, truoc la 7.31. Van 0 loi bo cuc.

Co-Authored-By: Claude Opus 5 <noreply@anthropic.com>
</commit_message>
<xml_diff>
--- a/VNPAY-seminar.pptx
+++ b/VNPAY-seminar.pptx
@@ -3146,7 +3146,7 @@
                 <a:solidFill>
                   <a:srgbClr val="0A5BA8"/>
                 </a:solidFill>
-                <a:latin typeface="Calibri"/>
+                <a:latin typeface="Arial"/>
               </a:rPr>
               <a:t>SEMINAR</a:t>
             </a:r>
@@ -3162,7 +3162,7 @@
                 <a:solidFill>
                   <a:srgbClr val="16181D"/>
                 </a:solidFill>
-                <a:latin typeface="Calibri"/>
+                <a:latin typeface="Arial"/>
               </a:rPr>
               <a:t>Nhúng VNPAY vào một cửa hàng có sẵn</a:t>
             </a:r>
@@ -3178,7 +3178,7 @@
                 <a:solidFill>
                   <a:srgbClr val="6B7788"/>
                 </a:solidFill>
-                <a:latin typeface="Calibri"/>
+                <a:latin typeface="Arial"/>
               </a:rPr>
               <a:t>Mở file ShopStart.java đã tải trước. Hôm nay mình điền 6 chỗ TODO trong đó.</a:t>
             </a:r>
@@ -3194,7 +3194,7 @@
                 <a:solidFill>
                   <a:srgbClr val="6B7788"/>
                 </a:solidFill>
-                <a:latin typeface="Calibri"/>
+                <a:latin typeface="Arial"/>
               </a:rPr>
               <a:t>Cần JDK 17 trở lên. Không cần Maven, không cần cài thư viện nào.</a:t>
             </a:r>
@@ -3259,7 +3259,7 @@
                 <a:solidFill>
                   <a:srgbClr val="0A5BA8"/>
                 </a:solidFill>
-                <a:latin typeface="Calibri"/>
+                <a:latin typeface="Arial"/>
               </a:rPr>
               <a:t>DỪNG LẠI KIỂM TRA</a:t>
             </a:r>
@@ -3275,7 +3275,7 @@
                 <a:solidFill>
                   <a:srgbClr val="16181D"/>
                 </a:solidFill>
-                <a:latin typeface="Calibri"/>
+                <a:latin typeface="Arial"/>
               </a:rPr>
               <a:t>Chạy thử đã, đừng viết tiếp</a:t>
             </a:r>
@@ -3291,7 +3291,7 @@
         <p:spPr>
           <a:xfrm>
             <a:off x="566928" y="1425447"/>
-            <a:ext cx="11057839" cy="1362456"/>
+            <a:ext cx="11057839" cy="1122680"/>
           </a:xfrm>
           <a:prstGeom prst="rect">
             <a:avLst/>
@@ -3306,7 +3306,7 @@
           </a:ln>
         </p:spPr>
         <p:txBody>
-          <a:bodyPr wrap="none" lIns="201168" rIns="146304" tIns="128016" bIns="128016">
+          <a:bodyPr wrap="none" lIns="201168" rIns="146304" tIns="100584" bIns="82296">
             <a:spAutoFit/>
           </a:bodyPr>
           <a:lstStyle/>
@@ -3321,7 +3321,7 @@
                 <a:solidFill>
                   <a:srgbClr val="E4ECF5"/>
                 </a:solidFill>
-                <a:latin typeface="Consolas"/>
+                <a:latin typeface="Roboto Mono"/>
               </a:rPr>
               <a:t>export VNPAY_TMN_CODE=... VNPAY_HASH_SECRET=...</a:t>
             </a:r>
@@ -3337,7 +3337,7 @@
                 <a:solidFill>
                   <a:srgbClr val="E4ECF5"/>
                 </a:solidFill>
-                <a:latin typeface="Consolas"/>
+                <a:latin typeface="Roboto Mono"/>
               </a:rPr>
               <a:t>java ShopStart.java</a:t>
             </a:r>
@@ -3360,7 +3360,7 @@
                 <a:solidFill>
                   <a:srgbClr val="E4ECF5"/>
                 </a:solidFill>
-                <a:latin typeface="Consolas"/>
+                <a:latin typeface="Roboto Mono"/>
               </a:rPr>
               <a:t># mở http://localhost:8080, bấm Mua ngay rồi Thanh toán</a:t>
             </a:r>
@@ -3375,8 +3375,8 @@
         </p:nvSpPr>
         <p:spPr>
           <a:xfrm>
-            <a:off x="566928" y="2906775"/>
-            <a:ext cx="11057839" cy="843534"/>
+            <a:off x="566928" y="2666999"/>
+            <a:ext cx="11057839" cy="733044"/>
           </a:xfrm>
           <a:prstGeom prst="rect">
             <a:avLst/>
@@ -3406,7 +3406,7 @@
                 <a:solidFill>
                   <a:srgbClr val="0B6B47"/>
                 </a:solidFill>
-                <a:latin typeface="Calibri"/>
+                <a:latin typeface="Arial"/>
               </a:rPr>
               <a:t>Hiện ra form nhập thẻ NCB</a:t>
             </a:r>
@@ -3422,7 +3422,7 @@
                 <a:solidFill>
                   <a:srgbClr val="16181D"/>
                 </a:solidFill>
-                <a:latin typeface="Calibri"/>
+                <a:latin typeface="Arial"/>
               </a:rPr>
               <a:t>Chữ ký đúng rồi. Đi tiếp phần ngrok.</a:t>
             </a:r>
@@ -3437,8 +3437,8 @@
         </p:nvSpPr>
         <p:spPr>
           <a:xfrm>
-            <a:off x="566928" y="3869181"/>
-            <a:ext cx="11057839" cy="1100709"/>
+            <a:off x="566928" y="3518915"/>
+            <a:ext cx="11057839" cy="980694"/>
           </a:xfrm>
           <a:prstGeom prst="rect">
             <a:avLst/>
@@ -3468,7 +3468,7 @@
                 <a:solidFill>
                   <a:srgbClr val="C42B22"/>
                 </a:solidFill>
-                <a:latin typeface="Calibri"/>
+                <a:latin typeface="Arial"/>
               </a:rPr>
               <a:t>Báo Chữ ký không hợp lệ</a:t>
             </a:r>
@@ -3484,7 +3484,7 @@
                 <a:solidFill>
                   <a:srgbClr val="16181D"/>
                 </a:solidFill>
-                <a:latin typeface="Calibri"/>
+                <a:latin typeface="Arial"/>
               </a:rPr>
               <a:t>Sai HashSecret, hoặc quên encode ở TODO 2.</a:t>
             </a:r>
@@ -3500,7 +3500,7 @@
                 <a:solidFill>
                   <a:srgbClr val="16181D"/>
                 </a:solidFill>
-                <a:latin typeface="Calibri"/>
+                <a:latin typeface="Arial"/>
               </a:rPr>
               <a:t>Báo website không tồn tại thì là sai TmnCode, hoặc vnp_ReturnUrl không khớp domain đã khai.</a:t>
             </a:r>
@@ -3565,7 +3565,7 @@
                 <a:solidFill>
                   <a:srgbClr val="0A5BA8"/>
                 </a:solidFill>
-                <a:latin typeface="Calibri"/>
+                <a:latin typeface="Arial"/>
               </a:rPr>
               <a:t>BẮT BUỘC</a:t>
             </a:r>
@@ -3581,7 +3581,7 @@
                 <a:solidFill>
                   <a:srgbClr val="16181D"/>
                 </a:solidFill>
-                <a:latin typeface="Calibri"/>
+                <a:latin typeface="Arial"/>
               </a:rPr>
               <a:t>ngrok, để VNPAY với tới máy mình</a:t>
             </a:r>
@@ -3620,7 +3620,7 @@
                 <a:solidFill>
                   <a:srgbClr val="16181D"/>
                 </a:solidFill>
-                <a:latin typeface="Calibri"/>
+                <a:latin typeface="Arial"/>
               </a:rPr>
               <a:t>IPN là cuộc gọi từ server VNPAY vào server mình. Máy ở localhost thì từ internet không ai thấy.</a:t>
             </a:r>
@@ -3636,7 +3636,7 @@
         <p:spPr>
           <a:xfrm>
             <a:off x="566928" y="2017267"/>
-            <a:ext cx="11057839" cy="1094994"/>
+            <a:ext cx="11057839" cy="901446"/>
           </a:xfrm>
           <a:prstGeom prst="rect">
             <a:avLst/>
@@ -3651,7 +3651,7 @@
           </a:ln>
         </p:spPr>
         <p:txBody>
-          <a:bodyPr wrap="none" lIns="201168" rIns="146304" tIns="128016" bIns="128016">
+          <a:bodyPr wrap="none" lIns="201168" rIns="146304" tIns="100584" bIns="82296">
             <a:spAutoFit/>
           </a:bodyPr>
           <a:lstStyle/>
@@ -3666,7 +3666,7 @@
                 <a:solidFill>
                   <a:srgbClr val="E4ECF5"/>
                 </a:solidFill>
-                <a:latin typeface="Consolas"/>
+                <a:latin typeface="Roboto Mono"/>
               </a:rPr>
               <a:t>ngrok http 8080</a:t>
             </a:r>
@@ -3689,7 +3689,7 @@
                 <a:solidFill>
                   <a:srgbClr val="E4ECF5"/>
                 </a:solidFill>
-                <a:latin typeface="Consolas"/>
+                <a:latin typeface="Roboto Mono"/>
               </a:rPr>
               <a:t>Forwarding   https://a1b2-42-115-242-109.ngrok-free.app -&gt; http://localhost:8080</a:t>
             </a:r>
@@ -3704,7 +3704,7 @@
         </p:nvSpPr>
         <p:spPr>
           <a:xfrm>
-            <a:off x="566928" y="3231133"/>
+            <a:off x="566928" y="3037585"/>
             <a:ext cx="11057839" cy="472948"/>
           </a:xfrm>
           <a:prstGeom prst="rect">
@@ -3728,7 +3728,7 @@
                 <a:solidFill>
                   <a:srgbClr val="16181D"/>
                 </a:solidFill>
-                <a:latin typeface="Calibri"/>
+                <a:latin typeface="Arial"/>
               </a:rPr>
               <a:t>Khai 2 URL vào sandbox.vnpayment.vn/merchantv2, mục Cấu hình, Thông tin website:</a:t>
             </a:r>
@@ -3743,8 +3743,8 @@
         </p:nvSpPr>
         <p:spPr>
           <a:xfrm>
-            <a:off x="566928" y="3822953"/>
-            <a:ext cx="11057839" cy="827532"/>
+            <a:off x="566928" y="3629405"/>
+            <a:ext cx="11057839" cy="680212"/>
           </a:xfrm>
           <a:prstGeom prst="rect">
             <a:avLst/>
@@ -3759,7 +3759,7 @@
           </a:ln>
         </p:spPr>
         <p:txBody>
-          <a:bodyPr wrap="none" lIns="201168" rIns="146304" tIns="128016" bIns="128016">
+          <a:bodyPr wrap="none" lIns="201168" rIns="146304" tIns="100584" bIns="82296">
             <a:spAutoFit/>
           </a:bodyPr>
           <a:lstStyle/>
@@ -3774,7 +3774,7 @@
                 <a:solidFill>
                   <a:srgbClr val="E4ECF5"/>
                 </a:solidFill>
-                <a:latin typeface="Consolas"/>
+                <a:latin typeface="Roboto Mono"/>
               </a:rPr>
               <a:t>URL trả về             https://a1b2-....ngrok-free.app/vnpay/return</a:t>
             </a:r>
@@ -3790,7 +3790,7 @@
                 <a:solidFill>
                   <a:srgbClr val="E4ECF5"/>
                 </a:solidFill>
-                <a:latin typeface="Consolas"/>
+                <a:latin typeface="Roboto Mono"/>
               </a:rPr>
               <a:t>URL nhận kết quả IPN   https://a1b2-....ngrok-free.app/vnpay/ipn</a:t>
             </a:r>
@@ -3805,8 +3805,8 @@
         </p:nvSpPr>
         <p:spPr>
           <a:xfrm>
-            <a:off x="566928" y="4769357"/>
-            <a:ext cx="11057839" cy="1100709"/>
+            <a:off x="566928" y="4428489"/>
+            <a:ext cx="11057839" cy="980694"/>
           </a:xfrm>
           <a:prstGeom prst="rect">
             <a:avLst/>
@@ -3836,7 +3836,7 @@
                 <a:solidFill>
                   <a:srgbClr val="C42B22"/>
                 </a:solidFill>
-                <a:latin typeface="Calibri"/>
+                <a:latin typeface="Arial"/>
               </a:rPr>
               <a:t>Hai chuyện của bản ngrok miễn phí</a:t>
             </a:r>
@@ -3852,7 +3852,7 @@
                 <a:solidFill>
                   <a:srgbClr val="16181D"/>
                 </a:solidFill>
-                <a:latin typeface="Calibri"/>
+                <a:latin typeface="Arial"/>
               </a:rPr>
               <a:t>Địa chỉ đổi mỗi lần chạy lại, phải khai lại trong portal. Làm sát giờ demo.</a:t>
             </a:r>
@@ -3868,7 +3868,7 @@
                 <a:solidFill>
                   <a:srgbClr val="16181D"/>
                 </a:solidFill>
-                <a:latin typeface="Calibri"/>
+                <a:latin typeface="Arial"/>
               </a:rPr>
               <a:t>Lần đầu mở bằng trình duyệt gặp trang cảnh báo, bấm Visit Site là qua. IPN không dính.</a:t>
             </a:r>
@@ -3933,7 +3933,7 @@
                 <a:solidFill>
                   <a:srgbClr val="0A5BA8"/>
                 </a:solidFill>
-                <a:latin typeface="Calibri"/>
+                <a:latin typeface="Arial"/>
               </a:rPr>
               <a:t>TODO 5</a:t>
             </a:r>
@@ -3949,7 +3949,7 @@
                 <a:solidFill>
                   <a:srgbClr val="16181D"/>
                 </a:solidFill>
-                <a:latin typeface="Calibri"/>
+                <a:latin typeface="Arial"/>
               </a:rPr>
               <a:t>Nhận IPN, nơi duy nhất được cộng tiền</a:t>
             </a:r>
@@ -3988,7 +3988,7 @@
                 <a:solidFill>
                   <a:srgbClr val="16181D"/>
                 </a:solidFill>
-                <a:latin typeface="Calibri"/>
+                <a:latin typeface="Arial"/>
               </a:rPr>
               <a:t>VNPAY retry tới khi nhận RspCode 00, nên hàm này gọi mấy lần cũng chỉ cộng tiền một lần.</a:t>
             </a:r>
@@ -4004,7 +4004,7 @@
         <p:spPr>
           <a:xfrm>
             <a:off x="566928" y="2017267"/>
-            <a:ext cx="11057839" cy="4664583"/>
+            <a:ext cx="11057839" cy="3854069"/>
           </a:xfrm>
           <a:prstGeom prst="rect">
             <a:avLst/>
@@ -4019,7 +4019,7 @@
           </a:ln>
         </p:spPr>
         <p:txBody>
-          <a:bodyPr wrap="none" lIns="201168" rIns="146304" tIns="128016" bIns="128016">
+          <a:bodyPr wrap="none" lIns="201168" rIns="146304" tIns="100584" bIns="82296">
             <a:spAutoFit/>
           </a:bodyPr>
           <a:lstStyle/>
@@ -4034,7 +4034,7 @@
                 <a:solidFill>
                   <a:srgbClr val="E4ECF5"/>
                 </a:solidFill>
-                <a:latin typeface="Consolas"/>
+                <a:latin typeface="Roboto Mono"/>
               </a:rPr>
               <a:t>if (!isValidSignature(params))</a:t>
             </a:r>
@@ -4050,7 +4050,7 @@
                 <a:solidFill>
                   <a:srgbClr val="E4ECF5"/>
                 </a:solidFill>
-                <a:latin typeface="Consolas"/>
+                <a:latin typeface="Roboto Mono"/>
               </a:rPr>
               <a:t>    return rsp("97", "Invalid Checksum");</a:t>
             </a:r>
@@ -4073,7 +4073,7 @@
                 <a:solidFill>
                   <a:srgbClr val="E4ECF5"/>
                 </a:solidFill>
-                <a:latin typeface="Consolas"/>
+                <a:latin typeface="Roboto Mono"/>
               </a:rPr>
               <a:t>Order order = ORDERS.get(params.get("vnp_TxnRef"));</a:t>
             </a:r>
@@ -4089,7 +4089,7 @@
                 <a:solidFill>
                   <a:srgbClr val="E4ECF5"/>
                 </a:solidFill>
-                <a:latin typeface="Consolas"/>
+                <a:latin typeface="Roboto Mono"/>
               </a:rPr>
               <a:t>if (order == null)              return rsp("01", "Order not Found");</a:t>
             </a:r>
@@ -4112,7 +4112,7 @@
                 <a:solidFill>
                   <a:srgbClr val="E4ECF5"/>
                 </a:solidFill>
-                <a:latin typeface="Consolas"/>
+                <a:latin typeface="Roboto Mono"/>
               </a:rPr>
               <a:t>if (Long.parseLong(params.get("vnp_Amount")) != order.amount * 100)</a:t>
             </a:r>
@@ -4128,7 +4128,7 @@
                 <a:solidFill>
                   <a:srgbClr val="E4ECF5"/>
                 </a:solidFill>
-                <a:latin typeface="Consolas"/>
+                <a:latin typeface="Roboto Mono"/>
               </a:rPr>
               <a:t>    return rsp("04", "Invalid Amount");        // chống sửa số tiền trên URL</a:t>
             </a:r>
@@ -4144,7 +4144,7 @@
                 <a:solidFill>
                   <a:srgbClr val="E4ECF5"/>
                 </a:solidFill>
-                <a:latin typeface="Consolas"/>
+                <a:latin typeface="Roboto Mono"/>
               </a:rPr>
               <a:t>synchronized (order) {</a:t>
             </a:r>
@@ -4160,7 +4160,7 @@
                 <a:solidFill>
                   <a:srgbClr val="E4ECF5"/>
                 </a:solidFill>
-                <a:latin typeface="Consolas"/>
+                <a:latin typeface="Roboto Mono"/>
               </a:rPr>
               <a:t>    if (!"PENDING".equals(order.status))</a:t>
             </a:r>
@@ -4176,7 +4176,7 @@
                 <a:solidFill>
                   <a:srgbClr val="E4ECF5"/>
                 </a:solidFill>
-                <a:latin typeface="Consolas"/>
+                <a:latin typeface="Roboto Mono"/>
               </a:rPr>
               <a:t>        return rsp("02", "Order already confirmed");</a:t>
             </a:r>
@@ -4199,7 +4199,7 @@
                 <a:solidFill>
                   <a:srgbClr val="E4ECF5"/>
                 </a:solidFill>
-                <a:latin typeface="Consolas"/>
+                <a:latin typeface="Roboto Mono"/>
               </a:rPr>
               <a:t>    boolean paid = "00".equals(params.get("vnp_ResponseCode"))</a:t>
             </a:r>
@@ -4215,7 +4215,7 @@
                 <a:solidFill>
                   <a:srgbClr val="E4ECF5"/>
                 </a:solidFill>
-                <a:latin typeface="Consolas"/>
+                <a:latin typeface="Roboto Mono"/>
               </a:rPr>
               <a:t>                &amp;&amp; "00".equals(params.get("vnp_TransactionStatus"));</a:t>
             </a:r>
@@ -4231,7 +4231,7 @@
                 <a:solidFill>
                   <a:srgbClr val="E4ECF5"/>
                 </a:solidFill>
-                <a:latin typeface="Consolas"/>
+                <a:latin typeface="Roboto Mono"/>
               </a:rPr>
               <a:t>    order.status = paid ? "PAID" : "FAILED";</a:t>
             </a:r>
@@ -4247,7 +4247,7 @@
                 <a:solidFill>
                   <a:srgbClr val="E4ECF5"/>
                 </a:solidFill>
-                <a:latin typeface="Consolas"/>
+                <a:latin typeface="Roboto Mono"/>
               </a:rPr>
               <a:t>}</a:t>
             </a:r>
@@ -4263,7 +4263,7 @@
                 <a:solidFill>
                   <a:srgbClr val="E4ECF5"/>
                 </a:solidFill>
-                <a:latin typeface="Consolas"/>
+                <a:latin typeface="Roboto Mono"/>
               </a:rPr>
               <a:t>return rsp("00", "Confirm Success");           // VNPAY ngừng retry</a:t>
             </a:r>
@@ -4328,7 +4328,7 @@
                 <a:solidFill>
                   <a:srgbClr val="0A5BA8"/>
                 </a:solidFill>
-                <a:latin typeface="Calibri"/>
+                <a:latin typeface="Arial"/>
               </a:rPr>
               <a:t>TODO 6</a:t>
             </a:r>
@@ -4344,7 +4344,7 @@
                 <a:solidFill>
                   <a:srgbClr val="16181D"/>
                 </a:solidFill>
-                <a:latin typeface="Calibri"/>
+                <a:latin typeface="Arial"/>
               </a:rPr>
               <a:t>ReturnURL chỉ để vẽ màn hình</a:t>
             </a:r>
@@ -4383,7 +4383,7 @@
                 <a:solidFill>
                   <a:srgbClr val="6B7788"/>
                 </a:solidFill>
-                <a:latin typeface="Consolas"/>
+                <a:latin typeface="Roboto Mono"/>
               </a:rPr>
               <a:t>ShopStart.java</a:t>
             </a:r>
@@ -4399,7 +4399,7 @@
         <p:spPr>
           <a:xfrm>
             <a:off x="566928" y="1681479"/>
-            <a:ext cx="11057839" cy="1897380"/>
+            <a:ext cx="11057839" cy="1565148"/>
           </a:xfrm>
           <a:prstGeom prst="rect">
             <a:avLst/>
@@ -4414,7 +4414,7 @@
           </a:ln>
         </p:spPr>
         <p:txBody>
-          <a:bodyPr wrap="none" lIns="201168" rIns="146304" tIns="128016" bIns="128016">
+          <a:bodyPr wrap="none" lIns="201168" rIns="146304" tIns="100584" bIns="82296">
             <a:spAutoFit/>
           </a:bodyPr>
           <a:lstStyle/>
@@ -4429,7 +4429,7 @@
                 <a:solidFill>
                   <a:srgbClr val="E4ECF5"/>
                 </a:solidFill>
-                <a:latin typeface="Consolas"/>
+                <a:latin typeface="Roboto Mono"/>
               </a:rPr>
               <a:t>static String handleReturn(Map&lt;String, String&gt; params) {</a:t>
             </a:r>
@@ -4445,7 +4445,7 @@
                 <a:solidFill>
                   <a:srgbClr val="E4ECF5"/>
                 </a:solidFill>
-                <a:latin typeface="Consolas"/>
+                <a:latin typeface="Roboto Mono"/>
               </a:rPr>
               <a:t>    boolean valid = isValidSignature(params);</a:t>
             </a:r>
@@ -4461,7 +4461,7 @@
                 <a:solidFill>
                   <a:srgbClr val="E4ECF5"/>
                 </a:solidFill>
-                <a:latin typeface="Consolas"/>
+                <a:latin typeface="Roboto Mono"/>
               </a:rPr>
               <a:t>    String txnRef = params.getOrDefault("vnp_TxnRef", "");</a:t>
             </a:r>
@@ -4484,7 +4484,7 @@
                 <a:solidFill>
                   <a:srgbClr val="E4ECF5"/>
                 </a:solidFill>
-                <a:latin typeface="Consolas"/>
+                <a:latin typeface="Roboto Mono"/>
               </a:rPr>
               <a:t>    return "/?txnRef=" + encode(txnRef) + "&amp;valid=" + valid;</a:t>
             </a:r>
@@ -4500,7 +4500,7 @@
                 <a:solidFill>
                   <a:srgbClr val="E4ECF5"/>
                 </a:solidFill>
-                <a:latin typeface="Consolas"/>
+                <a:latin typeface="Roboto Mono"/>
               </a:rPr>
               <a:t>}</a:t>
             </a:r>
@@ -4515,7 +4515,7 @@
         </p:nvSpPr>
         <p:spPr>
           <a:xfrm>
-            <a:off x="566928" y="3697731"/>
+            <a:off x="566928" y="3365499"/>
             <a:ext cx="11057839" cy="836168"/>
           </a:xfrm>
           <a:prstGeom prst="rect">
@@ -4539,7 +4539,7 @@
                 <a:solidFill>
                   <a:srgbClr val="16181D"/>
                 </a:solidFill>
-                <a:latin typeface="Calibri"/>
+                <a:latin typeface="Arial"/>
               </a:rPr>
               <a:t>Để ý cái KHÔNG có ở đây: không dòng nào đổi trạng thái đơn hàng.</a:t>
             </a:r>
@@ -4555,7 +4555,7 @@
                 <a:solidFill>
                   <a:srgbClr val="16181D"/>
                 </a:solidFill>
-                <a:latin typeface="Calibri"/>
+                <a:latin typeface="Arial"/>
               </a:rPr>
               <a:t>Tham số trên trình duyệt là dữ liệu do khách mang về, không phải sự thật.</a:t>
             </a:r>
@@ -4570,7 +4570,7 @@
         </p:nvSpPr>
         <p:spPr>
           <a:xfrm>
-            <a:off x="566928" y="4652771"/>
+            <a:off x="566928" y="4320539"/>
             <a:ext cx="11057839" cy="219456"/>
           </a:xfrm>
           <a:prstGeom prst="rect">
@@ -4594,7 +4594,7 @@
                 <a:solidFill>
                   <a:srgbClr val="6B7788"/>
                 </a:solidFill>
-                <a:latin typeface="Consolas"/>
+                <a:latin typeface="Roboto Mono"/>
               </a:rPr>
               <a:t>trang kết quả, phía trình duyệt</a:t>
             </a:r>
@@ -4609,8 +4609,8 @@
         </p:nvSpPr>
         <p:spPr>
           <a:xfrm>
-            <a:off x="566928" y="4908803"/>
-            <a:ext cx="11057839" cy="1629918"/>
+            <a:off x="566928" y="4576571"/>
+            <a:ext cx="11057839" cy="1343914"/>
           </a:xfrm>
           <a:prstGeom prst="rect">
             <a:avLst/>
@@ -4625,7 +4625,7 @@
           </a:ln>
         </p:spPr>
         <p:txBody>
-          <a:bodyPr wrap="none" lIns="201168" rIns="146304" tIns="128016" bIns="128016">
+          <a:bodyPr wrap="none" lIns="201168" rIns="146304" tIns="100584" bIns="82296">
             <a:spAutoFit/>
           </a:bodyPr>
           <a:lstStyle/>
@@ -4640,7 +4640,7 @@
                 <a:solidFill>
                   <a:srgbClr val="E4ECF5"/>
                 </a:solidFill>
-                <a:latin typeface="Consolas"/>
+                <a:latin typeface="Roboto Mono"/>
               </a:rPr>
               <a:t>// không đọc kết quả từ URL, hỏi lại server cho chắc</a:t>
             </a:r>
@@ -4656,7 +4656,7 @@
                 <a:solidFill>
                   <a:srgbClr val="E4ECF5"/>
                 </a:solidFill>
-                <a:latin typeface="Consolas"/>
+                <a:latin typeface="Roboto Mono"/>
               </a:rPr>
               <a:t>const res   = await fetch('/api/orders?txnRef=' + txnRef);</a:t>
             </a:r>
@@ -4672,7 +4672,7 @@
                 <a:solidFill>
                   <a:srgbClr val="E4ECF5"/>
                 </a:solidFill>
-                <a:latin typeface="Consolas"/>
+                <a:latin typeface="Roboto Mono"/>
               </a:rPr>
               <a:t>const order = await res.json();</a:t>
             </a:r>
@@ -4695,7 +4695,7 @@
                 <a:solidFill>
                   <a:srgbClr val="E4ECF5"/>
                 </a:solidFill>
-                <a:latin typeface="Consolas"/>
+                <a:latin typeface="Roboto Mono"/>
               </a:rPr>
               <a:t>if (order.status === 'PAID') showSuccess(order);</a:t>
             </a:r>
@@ -4760,7 +4760,7 @@
                 <a:solidFill>
                   <a:srgbClr val="0A5BA8"/>
                 </a:solidFill>
-                <a:latin typeface="Calibri"/>
+                <a:latin typeface="Arial"/>
               </a:rPr>
               <a:t>TÌNH HUỐNG THẬT</a:t>
             </a:r>
@@ -4776,7 +4776,7 @@
                 <a:solidFill>
                   <a:srgbClr val="16181D"/>
                 </a:solidFill>
-                <a:latin typeface="Calibri"/>
+                <a:latin typeface="Arial"/>
               </a:rPr>
               <a:t>Khi IPN không bao giờ về</a:t>
             </a:r>
@@ -4792,7 +4792,7 @@
         <p:spPr>
           <a:xfrm>
             <a:off x="566928" y="1425447"/>
-            <a:ext cx="11057839" cy="1357884"/>
+            <a:ext cx="11057839" cy="1228344"/>
           </a:xfrm>
           <a:prstGeom prst="rect">
             <a:avLst/>
@@ -4822,7 +4822,7 @@
                 <a:solidFill>
                   <a:srgbClr val="C42B22"/>
                 </a:solidFill>
-                <a:latin typeface="Calibri"/>
+                <a:latin typeface="Arial"/>
               </a:rPr>
               <a:t>Chuyện xảy ra lúc mình dựng bài này</a:t>
             </a:r>
@@ -4838,7 +4838,7 @@
                 <a:solidFill>
                   <a:srgbClr val="16181D"/>
                 </a:solidFill>
-                <a:latin typeface="Calibri"/>
+                <a:latin typeface="Arial"/>
               </a:rPr>
               <a:t>Portal sandbox không cho khai IPN URL. Danh sách website trống trơn,</a:t>
             </a:r>
@@ -4854,7 +4854,7 @@
                 <a:solidFill>
                   <a:srgbClr val="16181D"/>
                 </a:solidFill>
-                <a:latin typeface="Calibri"/>
+                <a:latin typeface="Arial"/>
               </a:rPr>
               <a:t>Cài đặt thông báo báo "Kết nối hệ thống tạm thời bị gián đoạn".</a:t>
             </a:r>
@@ -4870,7 +4870,7 @@
                 <a:solidFill>
                   <a:srgbClr val="16181D"/>
                 </a:solidFill>
-                <a:latin typeface="Calibri"/>
+                <a:latin typeface="Arial"/>
               </a:rPr>
               <a:t>Code đúng hết mà IPN không tới. Chỉ biết mỗi IPN thì demo chết tại chỗ.</a:t>
             </a:r>
@@ -4885,7 +4885,7 @@
         </p:nvSpPr>
         <p:spPr>
           <a:xfrm>
-            <a:off x="566928" y="2902203"/>
+            <a:off x="566928" y="2772663"/>
             <a:ext cx="11057839" cy="836168"/>
           </a:xfrm>
           <a:prstGeom prst="rect">
@@ -4909,7 +4909,7 @@
                 <a:solidFill>
                   <a:srgbClr val="16181D"/>
                 </a:solidFill>
-                <a:latin typeface="Calibri"/>
+                <a:latin typeface="Arial"/>
               </a:rPr>
               <a:t>Đường lùi là API querydr: server tự hỏi VNPAY trạng thái thật.</a:t>
             </a:r>
@@ -4925,7 +4925,7 @@
                 <a:solidFill>
                   <a:srgbClr val="16181D"/>
                 </a:solidFill>
-                <a:latin typeface="Calibri"/>
+                <a:latin typeface="Arial"/>
               </a:rPr>
               <a:t>Vẫn an toàn như IPN vì đủ ba lớp: hỏi thẳng VNPAY, verify chữ ký response, so lại số tiền.</a:t>
             </a:r>
@@ -4940,8 +4940,8 @@
         </p:nvSpPr>
         <p:spPr>
           <a:xfrm>
-            <a:off x="566928" y="3857243"/>
-            <a:ext cx="11057839" cy="1362456"/>
+            <a:off x="566928" y="3727703"/>
+            <a:ext cx="11057839" cy="1122680"/>
           </a:xfrm>
           <a:prstGeom prst="rect">
             <a:avLst/>
@@ -4956,7 +4956,7 @@
           </a:ln>
         </p:spPr>
         <p:txBody>
-          <a:bodyPr wrap="none" lIns="201168" rIns="146304" tIns="128016" bIns="128016">
+          <a:bodyPr wrap="none" lIns="201168" rIns="146304" tIns="100584" bIns="82296">
             <a:spAutoFit/>
           </a:bodyPr>
           <a:lstStyle/>
@@ -4971,7 +4971,7 @@
                 <a:solidFill>
                   <a:srgbClr val="E4ECF5"/>
                 </a:solidFill>
-                <a:latin typeface="Consolas"/>
+                <a:latin typeface="Roboto Mono"/>
               </a:rPr>
               <a:t>// Hash của querydr không sort alphabet, nối bằng '|' đúng thứ tự tài liệu</a:t>
             </a:r>
@@ -4987,7 +4987,7 @@
                 <a:solidFill>
                   <a:srgbClr val="E4ECF5"/>
                 </a:solidFill>
-                <a:latin typeface="Consolas"/>
+                <a:latin typeface="Roboto Mono"/>
               </a:rPr>
               <a:t>String hashData = String.join("|",</a:t>
             </a:r>
@@ -5003,7 +5003,7 @@
                 <a:solidFill>
                   <a:srgbClr val="E4ECF5"/>
                 </a:solidFill>
-                <a:latin typeface="Consolas"/>
+                <a:latin typeface="Roboto Mono"/>
               </a:rPr>
               <a:t>        requestId, "2.1.0", "querydr", TMN_CODE,</a:t>
             </a:r>
@@ -5019,7 +5019,7 @@
                 <a:solidFill>
                   <a:srgbClr val="E4ECF5"/>
                 </a:solidFill>
-                <a:latin typeface="Consolas"/>
+                <a:latin typeface="Roboto Mono"/>
               </a:rPr>
               <a:t>        txnRef, transactionDate, createDate, ipAddr, orderInfo);</a:t>
             </a:r>
@@ -5034,8 +5034,8 @@
         </p:nvSpPr>
         <p:spPr>
           <a:xfrm>
-            <a:off x="566928" y="5338571"/>
-            <a:ext cx="11057839" cy="1100709"/>
+            <a:off x="566928" y="4969255"/>
+            <a:ext cx="11057839" cy="980694"/>
           </a:xfrm>
           <a:prstGeom prst="rect">
             <a:avLst/>
@@ -5065,7 +5065,7 @@
                 <a:solidFill>
                   <a:srgbClr val="0B6B47"/>
                 </a:solidFill>
-                <a:latin typeface="Calibri"/>
+                <a:latin typeface="Arial"/>
               </a:rPr>
               <a:t>Mang về dùng cho đồ án</a:t>
             </a:r>
@@ -5081,7 +5081,7 @@
                 <a:solidFill>
                   <a:srgbClr val="16181D"/>
                 </a:solidFill>
-                <a:latin typeface="Calibri"/>
+                <a:latin typeface="Arial"/>
               </a:rPr>
               <a:t>Một job @Scheduled quét đơn PENDING quá hạn rồi gọi querydr.</a:t>
             </a:r>
@@ -5097,7 +5097,7 @@
                 <a:solidFill>
                   <a:srgbClr val="16181D"/>
                 </a:solidFill>
-                <a:latin typeface="Calibri"/>
+                <a:latin typeface="Arial"/>
               </a:rPr>
               <a:t>Hệ thống thanh toán thật nào cũng có, vì IPN thất lạc là chuyện bình thường.</a:t>
             </a:r>
@@ -5162,7 +5162,7 @@
                 <a:solidFill>
                   <a:srgbClr val="0A5BA8"/>
                 </a:solidFill>
-                <a:latin typeface="Calibri"/>
+                <a:latin typeface="Arial"/>
               </a:rPr>
               <a:t>DEMO</a:t>
             </a:r>
@@ -5178,7 +5178,7 @@
                 <a:solidFill>
                   <a:srgbClr val="16181D"/>
                 </a:solidFill>
-                <a:latin typeface="Calibri"/>
+                <a:latin typeface="Arial"/>
               </a:rPr>
               <a:t>Quẹt thẻ thật trên sandbox</a:t>
             </a:r>
@@ -5194,7 +5194,7 @@
         <p:spPr>
           <a:xfrm>
             <a:off x="566928" y="1425447"/>
-            <a:ext cx="11057839" cy="1362456"/>
+            <a:ext cx="11057839" cy="1122680"/>
           </a:xfrm>
           <a:prstGeom prst="rect">
             <a:avLst/>
@@ -5209,7 +5209,7 @@
           </a:ln>
         </p:spPr>
         <p:txBody>
-          <a:bodyPr wrap="none" lIns="201168" rIns="146304" tIns="128016" bIns="128016">
+          <a:bodyPr wrap="none" lIns="201168" rIns="146304" tIns="100584" bIns="82296">
             <a:spAutoFit/>
           </a:bodyPr>
           <a:lstStyle/>
@@ -5224,7 +5224,7 @@
                 <a:solidFill>
                   <a:srgbClr val="E4ECF5"/>
                 </a:solidFill>
-                <a:latin typeface="Consolas"/>
+                <a:latin typeface="Roboto Mono"/>
               </a:rPr>
               <a:t>Số thẻ          9704198526191432198</a:t>
             </a:r>
@@ -5240,7 +5240,7 @@
                 <a:solidFill>
                   <a:srgbClr val="E4ECF5"/>
                 </a:solidFill>
-                <a:latin typeface="Consolas"/>
+                <a:latin typeface="Roboto Mono"/>
               </a:rPr>
               <a:t>Tên chủ thẻ     NGUYEN VAN A</a:t>
             </a:r>
@@ -5256,7 +5256,7 @@
                 <a:solidFill>
                   <a:srgbClr val="E4ECF5"/>
                 </a:solidFill>
-                <a:latin typeface="Consolas"/>
+                <a:latin typeface="Roboto Mono"/>
               </a:rPr>
               <a:t>Ngày phát hành  07/15</a:t>
             </a:r>
@@ -5272,7 +5272,7 @@
                 <a:solidFill>
                   <a:srgbClr val="E4ECF5"/>
                 </a:solidFill>
-                <a:latin typeface="Consolas"/>
+                <a:latin typeface="Roboto Mono"/>
               </a:rPr>
               <a:t>OTP             123456</a:t>
             </a:r>
@@ -5287,7 +5287,7 @@
         </p:nvSpPr>
         <p:spPr>
           <a:xfrm>
-            <a:off x="566928" y="2906775"/>
+            <a:off x="566928" y="2666999"/>
             <a:ext cx="11057839" cy="472948"/>
           </a:xfrm>
           <a:prstGeom prst="rect">
@@ -5311,7 +5311,7 @@
                 <a:solidFill>
                   <a:srgbClr val="16181D"/>
                 </a:solidFill>
-                <a:latin typeface="Calibri"/>
+                <a:latin typeface="Arial"/>
               </a:rPr>
               <a:t>Log server lúc chốt đơn, nên mở sẵn cửa sổ terminal khi demo:</a:t>
             </a:r>
@@ -5326,8 +5326,8 @@
         </p:nvSpPr>
         <p:spPr>
           <a:xfrm>
-            <a:off x="566928" y="3498595"/>
-            <a:ext cx="11057839" cy="560070"/>
+            <a:off x="566928" y="3258819"/>
+            <a:ext cx="11057839" cy="458978"/>
           </a:xfrm>
           <a:prstGeom prst="rect">
             <a:avLst/>
@@ -5342,7 +5342,7 @@
           </a:ln>
         </p:spPr>
         <p:txBody>
-          <a:bodyPr wrap="none" lIns="201168" rIns="146304" tIns="128016" bIns="128016">
+          <a:bodyPr wrap="none" lIns="201168" rIns="146304" tIns="100584" bIns="82296">
             <a:spAutoFit/>
           </a:bodyPr>
           <a:lstStyle/>
@@ -5357,7 +5357,7 @@
                 <a:solidFill>
                   <a:srgbClr val="E4ECF5"/>
                 </a:solidFill>
-                <a:latin typeface="Consolas"/>
+                <a:latin typeface="Roboto Mono"/>
               </a:rPr>
               <a:t>Chot bang querydr: txnRef=20260920125606777443 status=PAID transactionNo=15683165</a:t>
             </a:r>
@@ -5372,8 +5372,8 @@
         </p:nvSpPr>
         <p:spPr>
           <a:xfrm>
-            <a:off x="566928" y="4177537"/>
-            <a:ext cx="11057839" cy="1100709"/>
+            <a:off x="566928" y="3836669"/>
+            <a:ext cx="11057839" cy="980694"/>
           </a:xfrm>
           <a:prstGeom prst="rect">
             <a:avLst/>
@@ -5403,7 +5403,7 @@
                 <a:solidFill>
                   <a:srgbClr val="0A5BA8"/>
                 </a:solidFill>
-                <a:latin typeface="Calibri"/>
+                <a:latin typeface="Arial"/>
               </a:rPr>
               <a:t>Phòng khi wifi trục trặc</a:t>
             </a:r>
@@ -5419,7 +5419,7 @@
                 <a:solidFill>
                   <a:srgbClr val="16181D"/>
                 </a:solidFill>
-                <a:latin typeface="Calibri"/>
+                <a:latin typeface="Arial"/>
               </a:rPr>
               <a:t>demo-local.sh tự ký IPN bằng chính HashSecret, diễn được cả ba ca:</a:t>
             </a:r>
@@ -5435,7 +5435,7 @@
                 <a:solidFill>
                   <a:srgbClr val="16181D"/>
                 </a:solidFill>
-                <a:latin typeface="Calibri"/>
+                <a:latin typeface="Arial"/>
               </a:rPr>
               <a:t>thành công ra 00, retry ra 02, bị sửa số tiền ra 97. Không cần internet, không cần bấm thẻ.</a:t>
             </a:r>
@@ -5500,7 +5500,7 @@
                 <a:solidFill>
                   <a:srgbClr val="0A5BA8"/>
                 </a:solidFill>
-                <a:latin typeface="Calibri"/>
+                <a:latin typeface="Arial"/>
               </a:rPr>
               <a:t>ĐƯA VÀO ĐỒ ÁN</a:t>
             </a:r>
@@ -5516,7 +5516,7 @@
                 <a:solidFill>
                   <a:srgbClr val="16181D"/>
                 </a:solidFill>
-                <a:latin typeface="Calibri"/>
+                <a:latin typeface="Arial"/>
               </a:rPr>
               <a:t>Từ file demo sang microservice</a:t>
             </a:r>
@@ -5532,7 +5532,7 @@
         <p:spPr>
           <a:xfrm>
             <a:off x="566928" y="1425447"/>
-            <a:ext cx="11057839" cy="2761488"/>
+            <a:ext cx="11057839" cy="2279904"/>
           </a:xfrm>
           <a:prstGeom prst="rect">
             <a:avLst/>
@@ -5547,7 +5547,7 @@
           </a:ln>
         </p:spPr>
         <p:txBody>
-          <a:bodyPr wrap="none" lIns="201168" rIns="146304" tIns="128016" bIns="128016">
+          <a:bodyPr wrap="none" lIns="201168" rIns="146304" tIns="100584" bIns="82296">
             <a:spAutoFit/>
           </a:bodyPr>
           <a:lstStyle/>
@@ -5562,7 +5562,7 @@
                 <a:solidFill>
                   <a:srgbClr val="E4ECF5"/>
                 </a:solidFill>
-                <a:latin typeface="Consolas"/>
+                <a:latin typeface="Roboto Mono"/>
               </a:rPr>
               <a:t>payment-service đứng riêng, service khác chỉ nghe event OrderPaid</a:t>
             </a:r>
@@ -5585,7 +5585,7 @@
                 <a:solidFill>
                   <a:srgbClr val="E4ECF5"/>
                 </a:solidFill>
-                <a:latin typeface="Consolas"/>
+                <a:latin typeface="Roboto Mono"/>
               </a:rPr>
               <a:t>HashSecret nạp từ Vault hoặc K8s Secret, không để trong application.yml</a:t>
             </a:r>
@@ -5608,7 +5608,7 @@
                 <a:solidFill>
                   <a:srgbClr val="E4ECF5"/>
                 </a:solidFill>
-                <a:latin typeface="Consolas"/>
+                <a:latin typeface="Roboto Mono"/>
               </a:rPr>
               <a:t>Bảng payment_transaction có UNIQUE(txn_ref) và optimistic lock</a:t>
             </a:r>
@@ -5624,7 +5624,7 @@
                 <a:solidFill>
                   <a:srgbClr val="E4ECF5"/>
                 </a:solidFill>
-                <a:latin typeface="Consolas"/>
+                <a:latin typeface="Roboto Mono"/>
               </a:rPr>
               <a:t>(demo dùng synchronized, chạy nhiều instance là không đủ)</a:t>
             </a:r>
@@ -5647,7 +5647,7 @@
                 <a:solidFill>
                   <a:srgbClr val="E4ECF5"/>
                 </a:solidFill>
-                <a:latin typeface="Consolas"/>
+                <a:latin typeface="Roboto Mono"/>
               </a:rPr>
               <a:t>Nhiều cổng thanh toán thì bọc sau interface PaymentGateway</a:t>
             </a:r>
@@ -5662,7 +5662,7 @@
         </p:nvSpPr>
         <p:spPr>
           <a:xfrm>
-            <a:off x="566928" y="4305807"/>
+            <a:off x="566928" y="3824223"/>
             <a:ext cx="11057839" cy="1199388"/>
           </a:xfrm>
           <a:prstGeom prst="rect">
@@ -5686,7 +5686,7 @@
                 <a:solidFill>
                   <a:srgbClr val="16181D"/>
                 </a:solidFill>
-                <a:latin typeface="Calibri"/>
+                <a:latin typeface="Arial"/>
               </a:rPr>
               <a:t>Đồ án nào dùng được ngay: bất kỳ chỗ nào có đặt hàng hoặc nạp tiền.</a:t>
             </a:r>
@@ -5702,7 +5702,7 @@
                 <a:solidFill>
                   <a:srgbClr val="16181D"/>
                 </a:solidFill>
-                <a:latin typeface="Calibri"/>
+                <a:latin typeface="Arial"/>
               </a:rPr>
               <a:t>Bán hàng online, đặt vé, đặt sân, đóng học phí, ví điện tử, quyên góp.</a:t>
             </a:r>
@@ -5718,7 +5718,7 @@
                 <a:solidFill>
                   <a:srgbClr val="16181D"/>
                 </a:solidFill>
-                <a:latin typeface="Calibri"/>
+                <a:latin typeface="Arial"/>
               </a:rPr>
               <a:t>Việc phải làm chỉ là thay chỗ lưu đơn hàng bằng repository của mình.</a:t>
             </a:r>
@@ -5783,7 +5783,7 @@
                 <a:solidFill>
                   <a:srgbClr val="0A5BA8"/>
                 </a:solidFill>
-                <a:latin typeface="Calibri"/>
+                <a:latin typeface="Arial"/>
               </a:rPr>
               <a:t>TỔNG KẾT</a:t>
             </a:r>
@@ -5799,7 +5799,7 @@
                 <a:solidFill>
                   <a:srgbClr val="16181D"/>
                 </a:solidFill>
-                <a:latin typeface="Calibri"/>
+                <a:latin typeface="Arial"/>
               </a:rPr>
               <a:t>Sáu điều nên nhớ</a:t>
             </a:r>
@@ -5815,7 +5815,7 @@
         <p:spPr>
           <a:xfrm>
             <a:off x="566928" y="1425447"/>
-            <a:ext cx="11057839" cy="2144268"/>
+            <a:ext cx="11057839" cy="1769364"/>
           </a:xfrm>
           <a:prstGeom prst="rect">
             <a:avLst/>
@@ -5830,7 +5830,7 @@
           </a:ln>
         </p:spPr>
         <p:txBody>
-          <a:bodyPr wrap="none" lIns="201168" rIns="146304" tIns="128016" bIns="128016">
+          <a:bodyPr wrap="none" lIns="201168" rIns="146304" tIns="100584" bIns="82296">
             <a:spAutoFit/>
           </a:bodyPr>
           <a:lstStyle/>
@@ -5845,7 +5845,7 @@
                 <a:solidFill>
                   <a:srgbClr val="E4ECF5"/>
                 </a:solidFill>
-                <a:latin typeface="Consolas"/>
+                <a:latin typeface="Roboto Mono"/>
               </a:rPr>
               <a:t>1. Chỉ tin IPN và querydr, hai kênh server gọi server</a:t>
             </a:r>
@@ -5861,7 +5861,7 @@
                 <a:solidFill>
                   <a:srgbClr val="E4ECF5"/>
                 </a:solidFill>
-                <a:latin typeface="Consolas"/>
+                <a:latin typeface="Roboto Mono"/>
               </a:rPr>
               <a:t>2. So lại số tiền với đơn trong DB trước khi đánh dấu PAID</a:t>
             </a:r>
@@ -5877,7 +5877,7 @@
                 <a:solidFill>
                   <a:srgbClr val="E4ECF5"/>
                 </a:solidFill>
-                <a:latin typeface="Consolas"/>
+                <a:latin typeface="Roboto Mono"/>
               </a:rPr>
               <a:t>3. Idempotent bằng trạng thái đơn, đã xử lý thì trả 02</a:t>
             </a:r>
@@ -5893,7 +5893,7 @@
                 <a:solidFill>
                   <a:srgbClr val="E4ECF5"/>
                 </a:solidFill>
-                <a:latin typeface="Consolas"/>
+                <a:latin typeface="Roboto Mono"/>
               </a:rPr>
               <a:t>4. vnp_TxnRef duy nhất trong 24h, thanh toán lại phải sinh mã mới</a:t>
             </a:r>
@@ -5909,7 +5909,7 @@
                 <a:solidFill>
                   <a:srgbClr val="E4ECF5"/>
                 </a:solidFill>
-                <a:latin typeface="Consolas"/>
+                <a:latin typeface="Roboto Mono"/>
               </a:rPr>
               <a:t>5. Giờ Asia/Ho_Chi_Minh, đừng dùng Etc/GMT+7</a:t>
             </a:r>
@@ -5925,7 +5925,7 @@
                 <a:solidFill>
                   <a:srgbClr val="E4ECF5"/>
                 </a:solidFill>
-                <a:latin typeface="Consolas"/>
+                <a:latin typeface="Roboto Mono"/>
               </a:rPr>
               <a:t>6. Không log secret, không log chữ ký</a:t>
             </a:r>
@@ -5940,8 +5940,8 @@
         </p:nvSpPr>
         <p:spPr>
           <a:xfrm>
-            <a:off x="566928" y="3688587"/>
-            <a:ext cx="11057839" cy="843534"/>
+            <a:off x="566928" y="3313683"/>
+            <a:ext cx="11057839" cy="733044"/>
           </a:xfrm>
           <a:prstGeom prst="rect">
             <a:avLst/>
@@ -5971,7 +5971,7 @@
                 <a:solidFill>
                   <a:srgbClr val="0A5BA8"/>
                 </a:solidFill>
-                <a:latin typeface="Calibri"/>
+                <a:latin typeface="Arial"/>
               </a:rPr>
               <a:t>Nếu chỉ nhớ được một câu</a:t>
             </a:r>
@@ -5987,7 +5987,7 @@
                 <a:solidFill>
                   <a:srgbClr val="16181D"/>
                 </a:solidFill>
-                <a:latin typeface="Calibri"/>
+                <a:latin typeface="Arial"/>
               </a:rPr>
               <a:t>Tham số trên trình duyệt là dữ liệu do khách mang về, không phải sự thật.</a:t>
             </a:r>
@@ -6002,7 +6002,7 @@
         </p:nvSpPr>
         <p:spPr>
           <a:xfrm>
-            <a:off x="566928" y="4650993"/>
+            <a:off x="566928" y="4165599"/>
             <a:ext cx="11057839" cy="767588"/>
           </a:xfrm>
           <a:prstGeom prst="rect">
@@ -6026,7 +6026,7 @@
                 <a:solidFill>
                   <a:srgbClr val="16181D"/>
                 </a:solidFill>
-                <a:latin typeface="Calibri"/>
+                <a:latin typeface="Arial"/>
               </a:rPr>
               <a:t>Giới hạn: bắt buộc redirect nên app mobile phải nhúng WebView. Sandbox không giống</a:t>
             </a:r>
@@ -6042,7 +6042,7 @@
                 <a:solidFill>
                   <a:srgbClr val="16181D"/>
                 </a:solidFill>
-                <a:latin typeface="Calibri"/>
+                <a:latin typeface="Arial"/>
               </a:rPr>
               <a:t>production 100%. Hoàn tiền phải gọi API refund rồi đối soát tay. ngrok free đổi địa chỉ mỗi lần chạy.</a:t>
             </a:r>
@@ -6107,7 +6107,7 @@
                 <a:solidFill>
                   <a:srgbClr val="0A5BA8"/>
                 </a:solidFill>
-                <a:latin typeface="Calibri"/>
+                <a:latin typeface="Arial"/>
               </a:rPr>
               <a:t>HỎI ĐÁP</a:t>
             </a:r>
@@ -6123,7 +6123,7 @@
                 <a:solidFill>
                   <a:srgbClr val="16181D"/>
                 </a:solidFill>
-                <a:latin typeface="Calibri"/>
+                <a:latin typeface="Arial"/>
               </a:rPr>
               <a:t>Mấy câu chắc sẽ bị hỏi</a:t>
             </a:r>
@@ -6162,7 +6162,7 @@
                 <a:solidFill>
                   <a:srgbClr val="16181D"/>
                 </a:solidFill>
-                <a:latin typeface="Calibri"/>
+                <a:latin typeface="Arial"/>
               </a:rPr>
               <a:t>IPN không về thì đơn treo mãi à?</a:t>
             </a:r>
@@ -6178,7 +6178,7 @@
                 <a:solidFill>
                   <a:srgbClr val="16181D"/>
                 </a:solidFill>
-                <a:latin typeface="Calibri"/>
+                <a:latin typeface="Arial"/>
               </a:rPr>
               <a:t>Không. Job quét đơn PENDING quá hạn rồi gọi querydr để chốt.</a:t>
             </a:r>
@@ -6201,7 +6201,7 @@
                 <a:solidFill>
                   <a:srgbClr val="16181D"/>
                 </a:solidFill>
-                <a:latin typeface="Calibri"/>
+                <a:latin typeface="Arial"/>
               </a:rPr>
               <a:t>Sao phải cài ngrok, không có cách nào khác?</a:t>
             </a:r>
@@ -6217,7 +6217,7 @@
                 <a:solidFill>
                   <a:srgbClr val="16181D"/>
                 </a:solidFill>
-                <a:latin typeface="Calibri"/>
+                <a:latin typeface="Arial"/>
               </a:rPr>
               <a:t>Cần một địa chỉ công khai để VNPAY gọi vào. Deploy lên server thật cũng được, nhưng chậm hơn.</a:t>
             </a:r>
@@ -6240,7 +6240,7 @@
                 <a:solidFill>
                   <a:srgbClr val="16181D"/>
                 </a:solidFill>
-                <a:latin typeface="Calibri"/>
+                <a:latin typeface="Arial"/>
               </a:rPr>
               <a:t>Báo sai chữ ký mà không hiểu vì sao?</a:t>
             </a:r>
@@ -6256,7 +6256,7 @@
                 <a:solidFill>
                   <a:srgbClr val="16181D"/>
                 </a:solidFill>
-                <a:latin typeface="Calibri"/>
+                <a:latin typeface="Arial"/>
               </a:rPr>
               <a:t>In hashData ra rồi so từng ký tự. Gần như luôn là quên URL-encode, hoặc quên bỏ vnp_SecureHash.</a:t>
             </a:r>
@@ -6279,7 +6279,7 @@
                 <a:solidFill>
                   <a:srgbClr val="16181D"/>
                 </a:solidFill>
-                <a:latin typeface="Calibri"/>
+                <a:latin typeface="Arial"/>
               </a:rPr>
               <a:t>Test được không nếu chưa có thẻ, chưa có mạng?</a:t>
             </a:r>
@@ -6295,7 +6295,7 @@
                 <a:solidFill>
                   <a:srgbClr val="16181D"/>
                 </a:solidFill>
-                <a:latin typeface="Calibri"/>
+                <a:latin typeface="Arial"/>
               </a:rPr>
               <a:t>Được, phần ký và verify có unit test chạy offline hoàn toàn.</a:t>
             </a:r>
@@ -6360,7 +6360,7 @@
                 <a:solidFill>
                   <a:srgbClr val="0A5BA8"/>
                 </a:solidFill>
-                <a:latin typeface="Calibri"/>
+                <a:latin typeface="Arial"/>
               </a:rPr>
               <a:t>BÀN GIAO</a:t>
             </a:r>
@@ -6376,7 +6376,7 @@
                 <a:solidFill>
                   <a:srgbClr val="16181D"/>
                 </a:solidFill>
-                <a:latin typeface="Calibri"/>
+                <a:latin typeface="Arial"/>
               </a:rPr>
               <a:t>Mang về dùng cho đồ án</a:t>
             </a:r>
@@ -6415,7 +6415,7 @@
                 <a:solidFill>
                   <a:srgbClr val="16181D"/>
                 </a:solidFill>
-                <a:latin typeface="Calibri"/>
+                <a:latin typeface="Arial"/>
               </a:rPr>
               <a:t>Sau buổi hôm nay mình bỏ bản làm xong vào đúng thư mục Drive lúc nãy.</a:t>
             </a:r>
@@ -6431,7 +6431,7 @@
         <p:spPr>
           <a:xfrm>
             <a:off x="566928" y="2017267"/>
-            <a:ext cx="11057839" cy="1527048"/>
+            <a:ext cx="11057839" cy="1258824"/>
           </a:xfrm>
           <a:prstGeom prst="rect">
             <a:avLst/>
@@ -6446,7 +6446,7 @@
           </a:ln>
         </p:spPr>
         <p:txBody>
-          <a:bodyPr wrap="none" lIns="201168" rIns="146304" tIns="128016" bIns="128016">
+          <a:bodyPr wrap="none" lIns="201168" rIns="146304" tIns="100584" bIns="82296">
             <a:spAutoFit/>
           </a:bodyPr>
           <a:lstStyle/>
@@ -6461,7 +6461,7 @@
                 <a:solidFill>
                   <a:srgbClr val="E4ECF5"/>
                 </a:solidFill>
-                <a:latin typeface="Consolas"/>
+                <a:latin typeface="Roboto Mono"/>
               </a:rPr>
               <a:t>VnpayDemo.java      bản đã điền xong 6 TODO</a:t>
             </a:r>
@@ -6477,7 +6477,7 @@
                 <a:solidFill>
                   <a:srgbClr val="E4ECF5"/>
                 </a:solidFill>
-                <a:latin typeface="Consolas"/>
+                <a:latin typeface="Roboto Mono"/>
               </a:rPr>
               <a:t>  Bước 4 và 5       hàm ký và verify chữ ký</a:t>
             </a:r>
@@ -6493,7 +6493,7 @@
                 <a:solidFill>
                   <a:srgbClr val="E4ECF5"/>
                 </a:solidFill>
-                <a:latin typeface="Consolas"/>
+                <a:latin typeface="Roboto Mono"/>
               </a:rPr>
               <a:t>  Bước 8            đối soát khi IPN không về</a:t>
             </a:r>
@@ -6509,7 +6509,7 @@
                 <a:solidFill>
                   <a:srgbClr val="E4ECF5"/>
                 </a:solidFill>
-                <a:latin typeface="Consolas"/>
+                <a:latin typeface="Roboto Mono"/>
               </a:rPr>
               <a:t>  VNPAY_MODE        chạy có ngrok hay không ngrok</a:t>
             </a:r>
@@ -6524,8 +6524,8 @@
         </p:nvSpPr>
         <p:spPr>
           <a:xfrm>
-            <a:off x="566928" y="3663187"/>
-            <a:ext cx="11057839" cy="1357884"/>
+            <a:off x="566928" y="3394963"/>
+            <a:ext cx="11057839" cy="1228344"/>
           </a:xfrm>
           <a:prstGeom prst="rect">
             <a:avLst/>
@@ -6555,7 +6555,7 @@
                 <a:solidFill>
                   <a:srgbClr val="0B6B47"/>
                 </a:solidFill>
-                <a:latin typeface="Calibri"/>
+                <a:latin typeface="Arial"/>
               </a:rPr>
               <a:t>Ba bước để nhét vào đồ án của bạn</a:t>
             </a:r>
@@ -6571,7 +6571,7 @@
                 <a:solidFill>
                   <a:srgbClr val="16181D"/>
                 </a:solidFill>
-                <a:latin typeface="Calibri"/>
+                <a:latin typeface="Arial"/>
               </a:rPr>
               <a:t>1. Copy hai hàm hmacSHA512 và buildQueryString sang project</a:t>
             </a:r>
@@ -6587,7 +6587,7 @@
                 <a:solidFill>
                   <a:srgbClr val="16181D"/>
                 </a:solidFill>
-                <a:latin typeface="Calibri"/>
+                <a:latin typeface="Arial"/>
               </a:rPr>
               <a:t>2. Thay chỗ lưu đơn hàng bằng repository sẵn có của bạn</a:t>
             </a:r>
@@ -6603,7 +6603,7 @@
                 <a:solidFill>
                   <a:srgbClr val="16181D"/>
                 </a:solidFill>
-                <a:latin typeface="Calibri"/>
+                <a:latin typeface="Arial"/>
               </a:rPr>
               <a:t>3. Nạp TmnCode và HashSecret từ biến môi trường, đừng hardcode</a:t>
             </a:r>
@@ -6618,7 +6618,7 @@
         </p:nvSpPr>
         <p:spPr>
           <a:xfrm>
-            <a:off x="566928" y="5139943"/>
+            <a:off x="566928" y="4742179"/>
             <a:ext cx="11057839" cy="457200"/>
           </a:xfrm>
           <a:prstGeom prst="rect">
@@ -6642,7 +6642,7 @@
                 <a:solidFill>
                   <a:srgbClr val="6B7788"/>
                 </a:solidFill>
-                <a:latin typeface="Calibri"/>
+                <a:latin typeface="Arial"/>
               </a:rPr>
               <a:t>Có gì không chạy cứ nhắn mình.</a:t>
             </a:r>
@@ -6707,7 +6707,7 @@
                 <a:solidFill>
                   <a:srgbClr val="0A5BA8"/>
                 </a:solidFill>
-                <a:latin typeface="Calibri"/>
+                <a:latin typeface="Arial"/>
               </a:rPr>
               <a:t>VẤN ĐỀ</a:t>
             </a:r>
@@ -6723,7 +6723,7 @@
                 <a:solidFill>
                   <a:srgbClr val="16181D"/>
                 </a:solidFill>
-                <a:latin typeface="Calibri"/>
+                <a:latin typeface="Arial"/>
               </a:rPr>
               <a:t>Tại sao phải qua cổng thanh toán</a:t>
             </a:r>
@@ -6762,7 +6762,7 @@
                 <a:solidFill>
                   <a:srgbClr val="16181D"/>
                 </a:solidFill>
-                <a:latin typeface="Calibri"/>
+                <a:latin typeface="Arial"/>
               </a:rPr>
               <a:t>Lưu số thẻ trên server của mình là vi phạm PCI-DSS, và ngân hàng không cấp API trực tiếp cho đồ án.</a:t>
             </a:r>
@@ -6778,7 +6778,7 @@
                 <a:solidFill>
                   <a:srgbClr val="16181D"/>
                 </a:solidFill>
-                <a:latin typeface="Calibri"/>
+                <a:latin typeface="Arial"/>
               </a:rPr>
               <a:t>VNPAY đảo ngược luồng: khách nhập thẻ trên trang của VNPAY, không phải trang của mình.</a:t>
             </a:r>
@@ -6794,7 +6794,7 @@
                 <a:solidFill>
                   <a:srgbClr val="16181D"/>
                 </a:solidFill>
-                <a:latin typeface="Calibri"/>
+                <a:latin typeface="Arial"/>
               </a:rPr>
               <a:t>Server mình chỉ trao đổi chữ ký, không bao giờ thấy số thẻ.</a:t>
             </a:r>
@@ -6810,7 +6810,7 @@
         <p:spPr>
           <a:xfrm>
             <a:off x="566928" y="2743707"/>
-            <a:ext cx="11057839" cy="1100709"/>
+            <a:ext cx="11057839" cy="980694"/>
           </a:xfrm>
           <a:prstGeom prst="rect">
             <a:avLst/>
@@ -6840,7 +6840,7 @@
                 <a:solidFill>
                   <a:srgbClr val="0A5BA8"/>
                 </a:solidFill>
-                <a:latin typeface="Calibri"/>
+                <a:latin typeface="Arial"/>
               </a:rPr>
               <a:t>Câu chốt cho cả buổi</a:t>
             </a:r>
@@ -6856,7 +6856,7 @@
                 <a:solidFill>
                   <a:srgbClr val="16181D"/>
                 </a:solidFill>
-                <a:latin typeface="Calibri"/>
+                <a:latin typeface="Arial"/>
               </a:rPr>
               <a:t>VNPAY không có SDK. Nó chỉ là redirect cộng một chữ ký HMAC-SHA512.</a:t>
             </a:r>
@@ -6872,7 +6872,7 @@
                 <a:solidFill>
                   <a:srgbClr val="16181D"/>
                 </a:solidFill>
-                <a:latin typeface="Calibri"/>
+                <a:latin typeface="Arial"/>
               </a:rPr>
               <a:t>Nắm được chữ ký là xong 90% bài toán.</a:t>
             </a:r>
@@ -6937,7 +6937,7 @@
                 <a:solidFill>
                   <a:srgbClr val="0A5BA8"/>
                 </a:solidFill>
-                <a:latin typeface="Calibri"/>
+                <a:latin typeface="Arial"/>
               </a:rPr>
               <a:t>KIẾN TRÚC</a:t>
             </a:r>
@@ -6953,7 +6953,7 @@
                 <a:solidFill>
                   <a:srgbClr val="16181D"/>
                 </a:solidFill>
-                <a:latin typeface="Calibri"/>
+                <a:latin typeface="Arial"/>
               </a:rPr>
               <a:t>Bốn đường đi, chỉ hai đường được tin</a:t>
             </a:r>
@@ -6969,7 +6969,7 @@
         <p:spPr>
           <a:xfrm>
             <a:off x="566928" y="1425447"/>
-            <a:ext cx="11057839" cy="2164842"/>
+            <a:ext cx="11057839" cy="1786382"/>
           </a:xfrm>
           <a:prstGeom prst="rect">
             <a:avLst/>
@@ -6984,7 +6984,7 @@
           </a:ln>
         </p:spPr>
         <p:txBody>
-          <a:bodyPr wrap="none" lIns="201168" rIns="146304" tIns="128016" bIns="128016">
+          <a:bodyPr wrap="none" lIns="201168" rIns="146304" tIns="100584" bIns="82296">
             <a:spAutoFit/>
           </a:bodyPr>
           <a:lstStyle/>
@@ -6999,7 +6999,7 @@
                 <a:solidFill>
                   <a:srgbClr val="E4ECF5"/>
                 </a:solidFill>
-                <a:latin typeface="Consolas"/>
+                <a:latin typeface="Roboto Mono"/>
               </a:rPr>
               <a:t>1. Browser -&gt; Server mình    tạo đơn PENDING, ký tham số, trả về paymentUrl</a:t>
             </a:r>
@@ -7022,7 +7022,7 @@
                 <a:solidFill>
                   <a:srgbClr val="E4ECF5"/>
                 </a:solidFill>
-                <a:latin typeface="Consolas"/>
+                <a:latin typeface="Roboto Mono"/>
               </a:rPr>
               <a:t>2. VNPAY   -&gt; Server mình    IPN, gọi thẳng server. TIN ĐƯỢC, cộng tiền ở đây</a:t>
             </a:r>
@@ -7045,7 +7045,7 @@
                 <a:solidFill>
                   <a:srgbClr val="E4ECF5"/>
                 </a:solidFill>
-                <a:latin typeface="Consolas"/>
+                <a:latin typeface="Roboto Mono"/>
               </a:rPr>
               <a:t>3. VNPAY   -&gt; Browser        ReturnURL. KHÔNG TIN, chỉ để vẽ màn hình</a:t>
             </a:r>
@@ -7068,7 +7068,7 @@
                 <a:solidFill>
                   <a:srgbClr val="E4ECF5"/>
                 </a:solidFill>
-                <a:latin typeface="Consolas"/>
+                <a:latin typeface="Roboto Mono"/>
               </a:rPr>
               <a:t>4. Server mình -&gt; VNPAY      querydr, hỏi lại trạng thái. TIN ĐƯỢC</a:t>
             </a:r>
@@ -7083,8 +7083,8 @@
         </p:nvSpPr>
         <p:spPr>
           <a:xfrm>
-            <a:off x="566928" y="3709161"/>
-            <a:ext cx="11057839" cy="1357884"/>
+            <a:off x="566928" y="3330701"/>
+            <a:ext cx="11057839" cy="1228344"/>
           </a:xfrm>
           <a:prstGeom prst="rect">
             <a:avLst/>
@@ -7114,7 +7114,7 @@
                 <a:solidFill>
                   <a:srgbClr val="C42B22"/>
                 </a:solidFill>
-                <a:latin typeface="Calibri"/>
+                <a:latin typeface="Arial"/>
               </a:rPr>
               <a:t>Hỏi cả lớp trước khi sang slide sau</a:t>
             </a:r>
@@ -7130,7 +7130,7 @@
                 <a:solidFill>
                   <a:srgbClr val="16181D"/>
                 </a:solidFill>
-                <a:latin typeface="Calibri"/>
+                <a:latin typeface="Arial"/>
               </a:rPr>
               <a:t>"Sao không cộng tiền luôn ở ReturnURL cho nhanh?"</a:t>
             </a:r>
@@ -7146,7 +7146,7 @@
                 <a:solidFill>
                   <a:srgbClr val="16181D"/>
                 </a:solidFill>
-                <a:latin typeface="Calibri"/>
+                <a:latin typeface="Arial"/>
               </a:rPr>
               <a:t>Vì đó là URL trên trình duyệt của khách. Sửa vnp_ResponseCode=00 là mua hàng miễn phí.</a:t>
             </a:r>
@@ -7162,7 +7162,7 @@
                 <a:solidFill>
                   <a:srgbClr val="16181D"/>
                 </a:solidFill>
-                <a:latin typeface="Calibri"/>
+                <a:latin typeface="Arial"/>
               </a:rPr>
               <a:t>Và khách tắt tab ngay sau khi trả tiền thì ReturnURL không bao giờ về.</a:t>
             </a:r>
@@ -7227,7 +7227,7 @@
                 <a:solidFill>
                   <a:srgbClr val="0A5BA8"/>
                 </a:solidFill>
-                <a:latin typeface="Calibri"/>
+                <a:latin typeface="Arial"/>
               </a:rPr>
               <a:t>LỘ TRÌNH</a:t>
             </a:r>
@@ -7243,7 +7243,7 @@
                 <a:solidFill>
                   <a:srgbClr val="16181D"/>
                 </a:solidFill>
-                <a:latin typeface="Calibri"/>
+                <a:latin typeface="Arial"/>
               </a:rPr>
               <a:t>Sáu chỗ trống trong ShopStart.java</a:t>
             </a:r>
@@ -7259,7 +7259,7 @@
         <p:spPr>
           <a:xfrm>
             <a:off x="566928" y="1425447"/>
-            <a:ext cx="11057839" cy="2144268"/>
+            <a:ext cx="11057839" cy="1769364"/>
           </a:xfrm>
           <a:prstGeom prst="rect">
             <a:avLst/>
@@ -7274,7 +7274,7 @@
           </a:ln>
         </p:spPr>
         <p:txBody>
-          <a:bodyPr wrap="none" lIns="201168" rIns="146304" tIns="128016" bIns="128016">
+          <a:bodyPr wrap="none" lIns="201168" rIns="146304" tIns="100584" bIns="82296">
             <a:spAutoFit/>
           </a:bodyPr>
           <a:lstStyle/>
@@ -7289,7 +7289,7 @@
                 <a:solidFill>
                   <a:srgbClr val="E4ECF5"/>
                 </a:solidFill>
-                <a:latin typeface="Consolas"/>
+                <a:latin typeface="Roboto Mono"/>
               </a:rPr>
               <a:t>TODO 1   Cấu hình TmnCode và HashSecret                    2 phút</a:t>
             </a:r>
@@ -7305,7 +7305,7 @@
                 <a:solidFill>
                   <a:srgbClr val="E4ECF5"/>
                 </a:solidFill>
-                <a:latin typeface="Consolas"/>
+                <a:latin typeface="Roboto Mono"/>
               </a:rPr>
               <a:t>TODO 2   Hàm ký HMAC-SHA512                                6 phút</a:t>
             </a:r>
@@ -7321,7 +7321,7 @@
                 <a:solidFill>
                   <a:srgbClr val="E4ECF5"/>
                 </a:solidFill>
-                <a:latin typeface="Consolas"/>
+                <a:latin typeface="Roboto Mono"/>
               </a:rPr>
               <a:t>TODO 3   Hàm verify chữ ký                                 3 phút</a:t>
             </a:r>
@@ -7337,7 +7337,7 @@
                 <a:solidFill>
                   <a:srgbClr val="E4ECF5"/>
                 </a:solidFill>
-                <a:latin typeface="Consolas"/>
+                <a:latin typeface="Roboto Mono"/>
               </a:rPr>
               <a:t>TODO 4   Tạo URL thanh toán                                5 phút</a:t>
             </a:r>
@@ -7353,7 +7353,7 @@
                 <a:solidFill>
                   <a:srgbClr val="E4ECF5"/>
                 </a:solidFill>
-                <a:latin typeface="Consolas"/>
+                <a:latin typeface="Roboto Mono"/>
               </a:rPr>
               <a:t>TODO 5   Nhận IPN                                          5 phút</a:t>
             </a:r>
@@ -7369,7 +7369,7 @@
                 <a:solidFill>
                   <a:srgbClr val="E4ECF5"/>
                 </a:solidFill>
-                <a:latin typeface="Consolas"/>
+                <a:latin typeface="Roboto Mono"/>
               </a:rPr>
               <a:t>TODO 6   ReturnURL và chốt trạng thái đơn                  4 phút</a:t>
             </a:r>
@@ -7384,7 +7384,7 @@
         </p:nvSpPr>
         <p:spPr>
           <a:xfrm>
-            <a:off x="566928" y="3688587"/>
+            <a:off x="566928" y="3313683"/>
             <a:ext cx="11057839" cy="836168"/>
           </a:xfrm>
           <a:prstGeom prst="rect">
@@ -7408,7 +7408,7 @@
                 <a:solidFill>
                   <a:srgbClr val="16181D"/>
                 </a:solidFill>
-                <a:latin typeface="Calibri"/>
+                <a:latin typeface="Arial"/>
               </a:rPr>
               <a:t>Phần đơn hàng, giao diện và server đã viết sẵn trong file, mình không đụng tới.</a:t>
             </a:r>
@@ -7424,7 +7424,7 @@
                 <a:solidFill>
                   <a:srgbClr val="16181D"/>
                 </a:solidFill>
-                <a:latin typeface="Calibri"/>
+                <a:latin typeface="Arial"/>
               </a:rPr>
               <a:t>Ai gõ không kịp cứ ngồi xem, cuối buổi mình gửi bản làm xong.</a:t>
             </a:r>
@@ -7489,7 +7489,7 @@
                 <a:solidFill>
                   <a:srgbClr val="0A5BA8"/>
                 </a:solidFill>
-                <a:latin typeface="Calibri"/>
+                <a:latin typeface="Arial"/>
               </a:rPr>
               <a:t>TODO 1</a:t>
             </a:r>
@@ -7505,7 +7505,7 @@
                 <a:solidFill>
                   <a:srgbClr val="16181D"/>
                 </a:solidFill>
-                <a:latin typeface="Calibri"/>
+                <a:latin typeface="Arial"/>
               </a:rPr>
               <a:t>Cấu hình</a:t>
             </a:r>
@@ -7544,7 +7544,7 @@
                 <a:solidFill>
                   <a:srgbClr val="6B7788"/>
                 </a:solidFill>
-                <a:latin typeface="Consolas"/>
+                <a:latin typeface="Roboto Mono"/>
               </a:rPr>
               <a:t>ShopStart.java</a:t>
             </a:r>
@@ -7560,7 +7560,7 @@
         <p:spPr>
           <a:xfrm>
             <a:off x="566928" y="1681479"/>
-            <a:ext cx="11057839" cy="2164842"/>
+            <a:ext cx="11057839" cy="1786382"/>
           </a:xfrm>
           <a:prstGeom prst="rect">
             <a:avLst/>
@@ -7575,7 +7575,7 @@
           </a:ln>
         </p:spPr>
         <p:txBody>
-          <a:bodyPr wrap="none" lIns="201168" rIns="146304" tIns="128016" bIns="128016">
+          <a:bodyPr wrap="none" lIns="201168" rIns="146304" tIns="100584" bIns="82296">
             <a:spAutoFit/>
           </a:bodyPr>
           <a:lstStyle/>
@@ -7590,7 +7590,7 @@
                 <a:solidFill>
                   <a:srgbClr val="E4ECF5"/>
                 </a:solidFill>
-                <a:latin typeface="Consolas"/>
+                <a:latin typeface="Roboto Mono"/>
               </a:rPr>
               <a:t>static final String TMN_CODE    = env("VNPAY_TMN_CODE", "CHANGE_ME");</a:t>
             </a:r>
@@ -7606,7 +7606,7 @@
                 <a:solidFill>
                   <a:srgbClr val="E4ECF5"/>
                 </a:solidFill>
-                <a:latin typeface="Consolas"/>
+                <a:latin typeface="Roboto Mono"/>
               </a:rPr>
               <a:t>static final String HASH_SECRET = env("VNPAY_HASH_SECRET", "CHANGE_ME");</a:t>
             </a:r>
@@ -7622,7 +7622,7 @@
                 <a:solidFill>
                   <a:srgbClr val="E4ECF5"/>
                 </a:solidFill>
-                <a:latin typeface="Consolas"/>
+                <a:latin typeface="Roboto Mono"/>
               </a:rPr>
               <a:t>static final String RETURN_URL  = env("VNPAY_RETURN_URL",</a:t>
             </a:r>
@@ -7638,7 +7638,7 @@
                 <a:solidFill>
                   <a:srgbClr val="E4ECF5"/>
                 </a:solidFill>
-                <a:latin typeface="Consolas"/>
+                <a:latin typeface="Roboto Mono"/>
               </a:rPr>
               <a:t>                                      "http://localhost:8080/vnpay/return");</a:t>
             </a:r>
@@ -7661,7 +7661,7 @@
                 <a:solidFill>
                   <a:srgbClr val="E4ECF5"/>
                 </a:solidFill>
-                <a:latin typeface="Consolas"/>
+                <a:latin typeface="Roboto Mono"/>
               </a:rPr>
               <a:t>static final String PAY_URL = "https://sandbox.vnpayment.vn/paymentv2/vpcpay.html";</a:t>
             </a:r>
@@ -7677,7 +7677,7 @@
                 <a:solidFill>
                   <a:srgbClr val="E4ECF5"/>
                 </a:solidFill>
-                <a:latin typeface="Consolas"/>
+                <a:latin typeface="Roboto Mono"/>
               </a:rPr>
               <a:t>static final String API_URL = "https://sandbox.vnpayment.vn/merchant_webapi/api/transaction";</a:t>
             </a:r>
@@ -7692,7 +7692,7 @@
         </p:nvSpPr>
         <p:spPr>
           <a:xfrm>
-            <a:off x="566928" y="3965193"/>
+            <a:off x="566928" y="3586733"/>
             <a:ext cx="11057839" cy="472948"/>
           </a:xfrm>
           <a:prstGeom prst="rect">
@@ -7716,7 +7716,7 @@
                 <a:solidFill>
                   <a:srgbClr val="16181D"/>
                 </a:solidFill>
-                <a:latin typeface="Calibri"/>
+                <a:latin typeface="Arial"/>
               </a:rPr>
               <a:t>Chạy app thì truyền qua biến môi trường:</a:t>
             </a:r>
@@ -7731,8 +7731,8 @@
         </p:nvSpPr>
         <p:spPr>
           <a:xfrm>
-            <a:off x="566928" y="4557013"/>
-            <a:ext cx="11057839" cy="1094994"/>
+            <a:off x="566928" y="4178553"/>
+            <a:ext cx="11057839" cy="901446"/>
           </a:xfrm>
           <a:prstGeom prst="rect">
             <a:avLst/>
@@ -7747,7 +7747,7 @@
           </a:ln>
         </p:spPr>
         <p:txBody>
-          <a:bodyPr wrap="none" lIns="201168" rIns="146304" tIns="128016" bIns="128016">
+          <a:bodyPr wrap="none" lIns="201168" rIns="146304" tIns="100584" bIns="82296">
             <a:spAutoFit/>
           </a:bodyPr>
           <a:lstStyle/>
@@ -7762,7 +7762,7 @@
                 <a:solidFill>
                   <a:srgbClr val="E4ECF5"/>
                 </a:solidFill>
-                <a:latin typeface="Consolas"/>
+                <a:latin typeface="Roboto Mono"/>
               </a:rPr>
               <a:t>export VNPAY_TMN_CODE=xxxxxxxx</a:t>
             </a:r>
@@ -7778,7 +7778,7 @@
                 <a:solidFill>
                   <a:srgbClr val="E4ECF5"/>
                 </a:solidFill>
-                <a:latin typeface="Consolas"/>
+                <a:latin typeface="Roboto Mono"/>
               </a:rPr>
               <a:t>export VNPAY_HASH_SECRET=xxxxxxxxxxxxxxxx</a:t>
             </a:r>
@@ -7794,7 +7794,7 @@
                 <a:solidFill>
                   <a:srgbClr val="E4ECF5"/>
                 </a:solidFill>
-                <a:latin typeface="Consolas"/>
+                <a:latin typeface="Roboto Mono"/>
               </a:rPr>
               <a:t>java ShopStart.java</a:t>
             </a:r>
@@ -7809,8 +7809,8 @@
         </p:nvSpPr>
         <p:spPr>
           <a:xfrm>
-            <a:off x="566928" y="5770879"/>
-            <a:ext cx="11057839" cy="843534"/>
+            <a:off x="566928" y="5198871"/>
+            <a:ext cx="11057839" cy="733044"/>
           </a:xfrm>
           <a:prstGeom prst="rect">
             <a:avLst/>
@@ -7840,7 +7840,7 @@
                 <a:solidFill>
                   <a:srgbClr val="C42B22"/>
                 </a:solidFill>
-                <a:latin typeface="Calibri"/>
+                <a:latin typeface="Arial"/>
               </a:rPr>
               <a:t>Đừng hardcode secret rồi push lên GitHub</a:t>
             </a:r>
@@ -7856,7 +7856,7 @@
                 <a:solidFill>
                   <a:srgbClr val="16181D"/>
                 </a:solidFill>
-                <a:latin typeface="Calibri"/>
+                <a:latin typeface="Arial"/>
               </a:rPr>
               <a:t>Ai clone repo cũng ký được đơn thay bạn. GitHub có bot quét chuyện này.</a:t>
             </a:r>
@@ -7921,7 +7921,7 @@
                 <a:solidFill>
                   <a:srgbClr val="0A5BA8"/>
                 </a:solidFill>
-                <a:latin typeface="Calibri"/>
+                <a:latin typeface="Arial"/>
               </a:rPr>
               <a:t>TODO 2</a:t>
             </a:r>
@@ -7937,7 +7937,7 @@
                 <a:solidFill>
                   <a:srgbClr val="16181D"/>
                 </a:solidFill>
-                <a:latin typeface="Calibri"/>
+                <a:latin typeface="Arial"/>
               </a:rPr>
               <a:t>Hàm ký, phần khó nhất</a:t>
             </a:r>
@@ -7976,7 +7976,7 @@
                 <a:solidFill>
                   <a:srgbClr val="16181D"/>
                 </a:solidFill>
-                <a:latin typeface="Calibri"/>
+                <a:latin typeface="Arial"/>
               </a:rPr>
               <a:t>Ba bước: sort alphabet, URL-encode giá trị, rồi HMAC-SHA512 ra hex chữ thường.</a:t>
             </a:r>
@@ -8015,7 +8015,7 @@
                 <a:solidFill>
                   <a:srgbClr val="6B7788"/>
                 </a:solidFill>
-                <a:latin typeface="Consolas"/>
+                <a:latin typeface="Roboto Mono"/>
               </a:rPr>
               <a:t>ShopStart.java</a:t>
             </a:r>
@@ -8031,7 +8031,7 @@
         <p:spPr>
           <a:xfrm>
             <a:off x="566928" y="2273299"/>
-            <a:ext cx="11057839" cy="3769614"/>
+            <a:ext cx="11057839" cy="3113786"/>
           </a:xfrm>
           <a:prstGeom prst="rect">
             <a:avLst/>
@@ -8046,7 +8046,7 @@
           </a:ln>
         </p:spPr>
         <p:txBody>
-          <a:bodyPr wrap="none" lIns="201168" rIns="146304" tIns="128016" bIns="128016">
+          <a:bodyPr wrap="none" lIns="201168" rIns="146304" tIns="100584" bIns="82296">
             <a:spAutoFit/>
           </a:bodyPr>
           <a:lstStyle/>
@@ -8061,7 +8061,7 @@
                 <a:solidFill>
                   <a:srgbClr val="E4ECF5"/>
                 </a:solidFill>
-                <a:latin typeface="Consolas"/>
+                <a:latin typeface="Roboto Mono"/>
               </a:rPr>
               <a:t>static String hmacSHA512(String secretKey, String data) {</a:t>
             </a:r>
@@ -8077,7 +8077,7 @@
                 <a:solidFill>
                   <a:srgbClr val="E4ECF5"/>
                 </a:solidFill>
-                <a:latin typeface="Consolas"/>
+                <a:latin typeface="Roboto Mono"/>
               </a:rPr>
               <a:t>    try {</a:t>
             </a:r>
@@ -8093,7 +8093,7 @@
                 <a:solidFill>
                   <a:srgbClr val="E4ECF5"/>
                 </a:solidFill>
-                <a:latin typeface="Consolas"/>
+                <a:latin typeface="Roboto Mono"/>
               </a:rPr>
               <a:t>        Mac mac = Mac.getInstance("HmacSHA512");</a:t>
             </a:r>
@@ -8109,7 +8109,7 @@
                 <a:solidFill>
                   <a:srgbClr val="E4ECF5"/>
                 </a:solidFill>
-                <a:latin typeface="Consolas"/>
+                <a:latin typeface="Roboto Mono"/>
               </a:rPr>
               <a:t>        mac.init(new SecretKeySpec(secretKey.getBytes(UTF_8), "HmacSHA512"));</a:t>
             </a:r>
@@ -8125,7 +8125,7 @@
                 <a:solidFill>
                   <a:srgbClr val="E4ECF5"/>
                 </a:solidFill>
-                <a:latin typeface="Consolas"/>
+                <a:latin typeface="Roboto Mono"/>
               </a:rPr>
               <a:t>        byte[] bytes = mac.doFinal(data.getBytes(UTF_8));</a:t>
             </a:r>
@@ -8148,7 +8148,7 @@
                 <a:solidFill>
                   <a:srgbClr val="E4ECF5"/>
                 </a:solidFill>
-                <a:latin typeface="Consolas"/>
+                <a:latin typeface="Roboto Mono"/>
               </a:rPr>
               <a:t>        StringBuilder hex = new StringBuilder(bytes.length * 2);</a:t>
             </a:r>
@@ -8164,7 +8164,7 @@
                 <a:solidFill>
                   <a:srgbClr val="E4ECF5"/>
                 </a:solidFill>
-                <a:latin typeface="Consolas"/>
+                <a:latin typeface="Roboto Mono"/>
               </a:rPr>
               <a:t>        for (byte b : bytes) hex.append(String.format("%02x", b));</a:t>
             </a:r>
@@ -8180,7 +8180,7 @@
                 <a:solidFill>
                   <a:srgbClr val="E4ECF5"/>
                 </a:solidFill>
-                <a:latin typeface="Consolas"/>
+                <a:latin typeface="Roboto Mono"/>
               </a:rPr>
               <a:t>        return hex.toString();                      // hex chữ thường</a:t>
             </a:r>
@@ -8196,7 +8196,7 @@
                 <a:solidFill>
                   <a:srgbClr val="E4ECF5"/>
                 </a:solidFill>
-                <a:latin typeface="Consolas"/>
+                <a:latin typeface="Roboto Mono"/>
               </a:rPr>
               <a:t>    } catch (Exception e) {</a:t>
             </a:r>
@@ -8212,7 +8212,7 @@
                 <a:solidFill>
                   <a:srgbClr val="E4ECF5"/>
                 </a:solidFill>
-                <a:latin typeface="Consolas"/>
+                <a:latin typeface="Roboto Mono"/>
               </a:rPr>
               <a:t>        throw new IllegalStateException("Không tạo được HMAC-SHA512", e);</a:t>
             </a:r>
@@ -8228,7 +8228,7 @@
                 <a:solidFill>
                   <a:srgbClr val="E4ECF5"/>
                 </a:solidFill>
-                <a:latin typeface="Consolas"/>
+                <a:latin typeface="Roboto Mono"/>
               </a:rPr>
               <a:t>    }</a:t>
             </a:r>
@@ -8244,7 +8244,7 @@
                 <a:solidFill>
                   <a:srgbClr val="E4ECF5"/>
                 </a:solidFill>
-                <a:latin typeface="Consolas"/>
+                <a:latin typeface="Roboto Mono"/>
               </a:rPr>
               <a:t>}</a:t>
             </a:r>
@@ -8309,7 +8309,7 @@
                 <a:solidFill>
                   <a:srgbClr val="0A5BA8"/>
                 </a:solidFill>
-                <a:latin typeface="Calibri"/>
+                <a:latin typeface="Arial"/>
               </a:rPr>
               <a:t>TODO 2</a:t>
             </a:r>
@@ -8325,7 +8325,7 @@
                 <a:solidFill>
                   <a:srgbClr val="16181D"/>
                 </a:solidFill>
-                <a:latin typeface="Calibri"/>
+                <a:latin typeface="Arial"/>
               </a:rPr>
               <a:t>Ráp chuỗi để đem đi băm</a:t>
             </a:r>
@@ -8364,7 +8364,7 @@
                 <a:solidFill>
                   <a:srgbClr val="6B7788"/>
                 </a:solidFill>
-                <a:latin typeface="Consolas"/>
+                <a:latin typeface="Roboto Mono"/>
               </a:rPr>
               <a:t>ShopStart.java</a:t>
             </a:r>
@@ -8380,7 +8380,7 @@
         <p:spPr>
           <a:xfrm>
             <a:off x="566928" y="1681479"/>
-            <a:ext cx="11057839" cy="3502152"/>
+            <a:ext cx="11057839" cy="2892552"/>
           </a:xfrm>
           <a:prstGeom prst="rect">
             <a:avLst/>
@@ -8395,7 +8395,7 @@
           </a:ln>
         </p:spPr>
         <p:txBody>
-          <a:bodyPr wrap="none" lIns="201168" rIns="146304" tIns="128016" bIns="128016">
+          <a:bodyPr wrap="none" lIns="201168" rIns="146304" tIns="100584" bIns="82296">
             <a:spAutoFit/>
           </a:bodyPr>
           <a:lstStyle/>
@@ -8410,7 +8410,7 @@
                 <a:solidFill>
                   <a:srgbClr val="E4ECF5"/>
                 </a:solidFill>
-                <a:latin typeface="Consolas"/>
+                <a:latin typeface="Roboto Mono"/>
               </a:rPr>
               <a:t>static String buildQueryString(Map&lt;String, String&gt; params) {</a:t>
             </a:r>
@@ -8426,7 +8426,7 @@
                 <a:solidFill>
                   <a:srgbClr val="E4ECF5"/>
                 </a:solidFill>
-                <a:latin typeface="Consolas"/>
+                <a:latin typeface="Roboto Mono"/>
               </a:rPr>
               <a:t>    StringBuilder sb = new StringBuilder();</a:t>
             </a:r>
@@ -8449,7 +8449,7 @@
                 <a:solidFill>
                   <a:srgbClr val="E4ECF5"/>
                 </a:solidFill>
-                <a:latin typeface="Consolas"/>
+                <a:latin typeface="Roboto Mono"/>
               </a:rPr>
               <a:t>    for (var e : new TreeMap&lt;&gt;(params).entrySet()) {          // 1. sort alphabet</a:t>
             </a:r>
@@ -8465,7 +8465,7 @@
                 <a:solidFill>
                   <a:srgbClr val="E4ECF5"/>
                 </a:solidFill>
-                <a:latin typeface="Consolas"/>
+                <a:latin typeface="Roboto Mono"/>
               </a:rPr>
               <a:t>        if (e.getValue() == null || e.getValue().isEmpty()) continue;</a:t>
             </a:r>
@@ -8481,7 +8481,7 @@
                 <a:solidFill>
                   <a:srgbClr val="E4ECF5"/>
                 </a:solidFill>
-                <a:latin typeface="Consolas"/>
+                <a:latin typeface="Roboto Mono"/>
               </a:rPr>
               <a:t>        if (sb.length() &gt; 0) sb.append('&amp;');</a:t>
             </a:r>
@@ -8504,7 +8504,7 @@
                 <a:solidFill>
                   <a:srgbClr val="E4ECF5"/>
                 </a:solidFill>
-                <a:latin typeface="Consolas"/>
+                <a:latin typeface="Roboto Mono"/>
               </a:rPr>
               <a:t>        sb.append(URLEncoder.encode(e.getKey(), US_ASCII)).append('=')</a:t>
             </a:r>
@@ -8520,7 +8520,7 @@
                 <a:solidFill>
                   <a:srgbClr val="E4ECF5"/>
                 </a:solidFill>
-                <a:latin typeface="Consolas"/>
+                <a:latin typeface="Roboto Mono"/>
               </a:rPr>
               <a:t>          .append(URLEncoder.encode(e.getValue(), US_ASCII));  // 2. encode giá trị</a:t>
             </a:r>
@@ -8536,7 +8536,7 @@
                 <a:solidFill>
                   <a:srgbClr val="E4ECF5"/>
                 </a:solidFill>
-                <a:latin typeface="Consolas"/>
+                <a:latin typeface="Roboto Mono"/>
               </a:rPr>
               <a:t>    }</a:t>
             </a:r>
@@ -8552,7 +8552,7 @@
                 <a:solidFill>
                   <a:srgbClr val="E4ECF5"/>
                 </a:solidFill>
-                <a:latin typeface="Consolas"/>
+                <a:latin typeface="Roboto Mono"/>
               </a:rPr>
               <a:t>    return sb.toString();</a:t>
             </a:r>
@@ -8568,7 +8568,7 @@
                 <a:solidFill>
                   <a:srgbClr val="E4ECF5"/>
                 </a:solidFill>
-                <a:latin typeface="Consolas"/>
+                <a:latin typeface="Roboto Mono"/>
               </a:rPr>
               <a:t>}</a:t>
             </a:r>
@@ -8583,8 +8583,8 @@
         </p:nvSpPr>
         <p:spPr>
           <a:xfrm>
-            <a:off x="566928" y="5302503"/>
-            <a:ext cx="11057839" cy="1100709"/>
+            <a:off x="566928" y="4692903"/>
+            <a:ext cx="11057839" cy="980694"/>
           </a:xfrm>
           <a:prstGeom prst="rect">
             <a:avLst/>
@@ -8614,7 +8614,7 @@
                 <a:solidFill>
                   <a:srgbClr val="C42B22"/>
                 </a:solidFill>
-                <a:latin typeface="Calibri"/>
+                <a:latin typeface="Arial"/>
               </a:rPr>
               <a:t>Đây là chỗ 90% người mới bị sai chữ ký</a:t>
             </a:r>
@@ -8630,7 +8630,7 @@
                 <a:solidFill>
                   <a:srgbClr val="16181D"/>
                 </a:solidFill>
-                <a:latin typeface="Calibri"/>
+                <a:latin typeface="Arial"/>
               </a:rPr>
               <a:t>Quên encode GIÁ TRỊ. vnp_OrderInfo có dấu cách là hỏng ngay.</a:t>
             </a:r>
@@ -8646,7 +8646,7 @@
                 <a:solidFill>
                   <a:srgbClr val="16181D"/>
                 </a:solidFill>
-                <a:latin typeface="Calibri"/>
+                <a:latin typeface="Arial"/>
               </a:rPr>
               <a:t>Để lọt tham số rỗng vào chuỗi. VNPAY bỏ qua chúng, mình giữ lại là lệch.</a:t>
             </a:r>
@@ -8711,7 +8711,7 @@
                 <a:solidFill>
                   <a:srgbClr val="0A5BA8"/>
                 </a:solidFill>
-                <a:latin typeface="Calibri"/>
+                <a:latin typeface="Arial"/>
               </a:rPr>
               <a:t>TODO 3</a:t>
             </a:r>
@@ -8727,7 +8727,7 @@
                 <a:solidFill>
                   <a:srgbClr val="16181D"/>
                 </a:solidFill>
-                <a:latin typeface="Calibri"/>
+                <a:latin typeface="Arial"/>
               </a:rPr>
               <a:t>Verify chữ ký khi VNPAY gọi về</a:t>
             </a:r>
@@ -8766,7 +8766,7 @@
                 <a:solidFill>
                   <a:srgbClr val="16181D"/>
                 </a:solidFill>
-                <a:latin typeface="Calibri"/>
+                <a:latin typeface="Arial"/>
               </a:rPr>
               <a:t>Dùng lại đúng hàm vừa viết, thêm một việc: bỏ chính chữ ký ra trước khi băm.</a:t>
             </a:r>
@@ -8805,7 +8805,7 @@
                 <a:solidFill>
                   <a:srgbClr val="6B7788"/>
                 </a:solidFill>
-                <a:latin typeface="Consolas"/>
+                <a:latin typeface="Roboto Mono"/>
               </a:rPr>
               <a:t>ShopStart.java</a:t>
             </a:r>
@@ -8821,7 +8821,7 @@
         <p:spPr>
           <a:xfrm>
             <a:off x="566928" y="2273299"/>
-            <a:ext cx="11057839" cy="3234690"/>
+            <a:ext cx="11057839" cy="2671318"/>
           </a:xfrm>
           <a:prstGeom prst="rect">
             <a:avLst/>
@@ -8836,7 +8836,7 @@
           </a:ln>
         </p:spPr>
         <p:txBody>
-          <a:bodyPr wrap="none" lIns="201168" rIns="146304" tIns="128016" bIns="128016">
+          <a:bodyPr wrap="none" lIns="201168" rIns="146304" tIns="100584" bIns="82296">
             <a:spAutoFit/>
           </a:bodyPr>
           <a:lstStyle/>
@@ -8851,7 +8851,7 @@
                 <a:solidFill>
                   <a:srgbClr val="E4ECF5"/>
                 </a:solidFill>
-                <a:latin typeface="Consolas"/>
+                <a:latin typeface="Roboto Mono"/>
               </a:rPr>
               <a:t>static boolean isValidSignature(Map&lt;String, String&gt; params) {</a:t>
             </a:r>
@@ -8867,7 +8867,7 @@
                 <a:solidFill>
                   <a:srgbClr val="E4ECF5"/>
                 </a:solidFill>
-                <a:latin typeface="Consolas"/>
+                <a:latin typeface="Roboto Mono"/>
               </a:rPr>
               <a:t>    String received = params.get("vnp_SecureHash");</a:t>
             </a:r>
@@ -8883,7 +8883,7 @@
                 <a:solidFill>
                   <a:srgbClr val="E4ECF5"/>
                 </a:solidFill>
-                <a:latin typeface="Consolas"/>
+                <a:latin typeface="Roboto Mono"/>
               </a:rPr>
               <a:t>    if (received == null || received.isBlank()) return false;</a:t>
             </a:r>
@@ -8906,7 +8906,7 @@
                 <a:solidFill>
                   <a:srgbClr val="E4ECF5"/>
                 </a:solidFill>
-                <a:latin typeface="Consolas"/>
+                <a:latin typeface="Roboto Mono"/>
               </a:rPr>
               <a:t>    Map&lt;String, String&gt; clone = new TreeMap&lt;&gt;(params);</a:t>
             </a:r>
@@ -8922,7 +8922,7 @@
                 <a:solidFill>
                   <a:srgbClr val="E4ECF5"/>
                 </a:solidFill>
-                <a:latin typeface="Consolas"/>
+                <a:latin typeface="Roboto Mono"/>
               </a:rPr>
               <a:t>    clone.remove("vnp_SecureHash");</a:t>
             </a:r>
@@ -8938,7 +8938,7 @@
                 <a:solidFill>
                   <a:srgbClr val="E4ECF5"/>
                 </a:solidFill>
-                <a:latin typeface="Consolas"/>
+                <a:latin typeface="Roboto Mono"/>
               </a:rPr>
               <a:t>    clone.remove("vnp_SecureHashType");</a:t>
             </a:r>
@@ -8961,7 +8961,7 @@
                 <a:solidFill>
                   <a:srgbClr val="E4ECF5"/>
                 </a:solidFill>
-                <a:latin typeface="Consolas"/>
+                <a:latin typeface="Roboto Mono"/>
               </a:rPr>
               <a:t>    String expected = hmacSHA512(HASH_SECRET, buildQueryString(clone));</a:t>
             </a:r>
@@ -8977,7 +8977,7 @@
                 <a:solidFill>
                   <a:srgbClr val="E4ECF5"/>
                 </a:solidFill>
-                <a:latin typeface="Consolas"/>
+                <a:latin typeface="Roboto Mono"/>
               </a:rPr>
               <a:t>    return constantTimeEquals(expected, received);</a:t>
             </a:r>
@@ -8993,7 +8993,7 @@
                 <a:solidFill>
                   <a:srgbClr val="E4ECF5"/>
                 </a:solidFill>
-                <a:latin typeface="Consolas"/>
+                <a:latin typeface="Roboto Mono"/>
               </a:rPr>
               <a:t>}</a:t>
             </a:r>
@@ -9008,8 +9008,8 @@
         </p:nvSpPr>
         <p:spPr>
           <a:xfrm>
-            <a:off x="566928" y="5626861"/>
-            <a:ext cx="11057839" cy="843534"/>
+            <a:off x="566928" y="5063489"/>
+            <a:ext cx="11057839" cy="733044"/>
           </a:xfrm>
           <a:prstGeom prst="rect">
             <a:avLst/>
@@ -9039,7 +9039,7 @@
                 <a:solidFill>
                   <a:srgbClr val="0A5BA8"/>
                 </a:solidFill>
-                <a:latin typeface="Calibri"/>
+                <a:latin typeface="Arial"/>
               </a:rPr>
               <a:t>Cách debug khi bí</a:t>
             </a:r>
@@ -9055,7 +9055,7 @@
                 <a:solidFill>
                   <a:srgbClr val="16181D"/>
                 </a:solidFill>
-                <a:latin typeface="Calibri"/>
+                <a:latin typeface="Arial"/>
               </a:rPr>
               <a:t>In buildQueryString(clone) ra rồi so từng ký tự với query string trên thanh địa chỉ.</a:t>
             </a:r>
@@ -9120,7 +9120,7 @@
                 <a:solidFill>
                   <a:srgbClr val="0A5BA8"/>
                 </a:solidFill>
-                <a:latin typeface="Calibri"/>
+                <a:latin typeface="Arial"/>
               </a:rPr>
               <a:t>TODO 4</a:t>
             </a:r>
@@ -9136,7 +9136,7 @@
                 <a:solidFill>
                   <a:srgbClr val="16181D"/>
                 </a:solidFill>
-                <a:latin typeface="Calibri"/>
+                <a:latin typeface="Arial"/>
               </a:rPr>
               <a:t>Ráp tham số và tạo URL</a:t>
             </a:r>
@@ -9152,7 +9152,7 @@
         <p:spPr>
           <a:xfrm>
             <a:off x="566928" y="1425447"/>
-            <a:ext cx="11057839" cy="1629918"/>
+            <a:ext cx="11057839" cy="1343914"/>
           </a:xfrm>
           <a:prstGeom prst="rect">
             <a:avLst/>
@@ -9167,7 +9167,7 @@
           </a:ln>
         </p:spPr>
         <p:txBody>
-          <a:bodyPr wrap="none" lIns="201168" rIns="146304" tIns="128016" bIns="128016">
+          <a:bodyPr wrap="none" lIns="201168" rIns="146304" tIns="100584" bIns="82296">
             <a:spAutoFit/>
           </a:bodyPr>
           <a:lstStyle/>
@@ -9182,7 +9182,7 @@
                 <a:solidFill>
                   <a:srgbClr val="E4ECF5"/>
                 </a:solidFill>
-                <a:latin typeface="Consolas"/>
+                <a:latin typeface="Roboto Mono"/>
               </a:rPr>
               <a:t>vnp_Amount       2500000                 nhân 100, số nguyên. 25.000đ -&gt; 2500000</a:t>
             </a:r>
@@ -9198,7 +9198,7 @@
                 <a:solidFill>
                   <a:srgbClr val="E4ECF5"/>
                 </a:solidFill>
-                <a:latin typeface="Consolas"/>
+                <a:latin typeface="Roboto Mono"/>
               </a:rPr>
               <a:t>vnp_TxnRef       20260920125606777443    duy nhất trong 24h theo TmnCode</a:t>
             </a:r>
@@ -9214,7 +9214,7 @@
                 <a:solidFill>
                   <a:srgbClr val="E4ECF5"/>
                 </a:solidFill>
-                <a:latin typeface="Consolas"/>
+                <a:latin typeface="Roboto Mono"/>
               </a:rPr>
               <a:t>vnp_CreateDate   20260920125606          giờ GMT+7, không phải giờ máy chủ</a:t>
             </a:r>
@@ -9230,7 +9230,7 @@
                 <a:solidFill>
                   <a:srgbClr val="E4ECF5"/>
                 </a:solidFill>
-                <a:latin typeface="Consolas"/>
+                <a:latin typeface="Roboto Mono"/>
               </a:rPr>
               <a:t>vnp_ReturnUrl    https://....ngrok...    phải khớp URL đã khai</a:t>
             </a:r>
@@ -9246,7 +9246,7 @@
                 <a:solidFill>
                   <a:srgbClr val="E4ECF5"/>
                 </a:solidFill>
-                <a:latin typeface="Consolas"/>
+                <a:latin typeface="Roboto Mono"/>
               </a:rPr>
               <a:t>vnp_BankCode     NCB                     bỏ trống thì VNPAY hiện trang chọn</a:t>
             </a:r>
@@ -9261,7 +9261,7 @@
         </p:nvSpPr>
         <p:spPr>
           <a:xfrm>
-            <a:off x="566928" y="3174237"/>
+            <a:off x="566928" y="2888233"/>
             <a:ext cx="11057839" cy="219456"/>
           </a:xfrm>
           <a:prstGeom prst="rect">
@@ -9285,7 +9285,7 @@
                 <a:solidFill>
                   <a:srgbClr val="6B7788"/>
                 </a:solidFill>
-                <a:latin typeface="Consolas"/>
+                <a:latin typeface="Roboto Mono"/>
               </a:rPr>
               <a:t>ShopStart.java</a:t>
             </a:r>
@@ -9300,8 +9300,8 @@
         </p:nvSpPr>
         <p:spPr>
           <a:xfrm>
-            <a:off x="566928" y="3430269"/>
-            <a:ext cx="11057839" cy="1897380"/>
+            <a:off x="566928" y="3144265"/>
+            <a:ext cx="11057839" cy="1565148"/>
           </a:xfrm>
           <a:prstGeom prst="rect">
             <a:avLst/>
@@ -9316,7 +9316,7 @@
           </a:ln>
         </p:spPr>
         <p:txBody>
-          <a:bodyPr wrap="none" lIns="201168" rIns="146304" tIns="128016" bIns="128016">
+          <a:bodyPr wrap="none" lIns="201168" rIns="146304" tIns="100584" bIns="82296">
             <a:spAutoFit/>
           </a:bodyPr>
           <a:lstStyle/>
@@ -9331,7 +9331,7 @@
                 <a:solidFill>
                   <a:srgbClr val="E4ECF5"/>
                 </a:solidFill>
-                <a:latin typeface="Consolas"/>
+                <a:latin typeface="Roboto Mono"/>
               </a:rPr>
               <a:t>p.put("vnp_Amount", String.valueOf(amount * 100));</a:t>
             </a:r>
@@ -9347,7 +9347,7 @@
                 <a:solidFill>
                   <a:srgbClr val="E4ECF5"/>
                 </a:solidFill>
-                <a:latin typeface="Consolas"/>
+                <a:latin typeface="Roboto Mono"/>
               </a:rPr>
               <a:t>p.put("vnp_CreateDate", now.format(VNP_TIME));</a:t>
             </a:r>
@@ -9363,7 +9363,7 @@
                 <a:solidFill>
                   <a:srgbClr val="E4ECF5"/>
                 </a:solidFill>
-                <a:latin typeface="Consolas"/>
+                <a:latin typeface="Roboto Mono"/>
               </a:rPr>
               <a:t>p.put("vnp_ExpireDate", now.plusMinutes(15).format(VNP_TIME));</a:t>
             </a:r>
@@ -9386,7 +9386,7 @@
                 <a:solidFill>
                   <a:srgbClr val="E4ECF5"/>
                 </a:solidFill>
-                <a:latin typeface="Consolas"/>
+                <a:latin typeface="Roboto Mono"/>
               </a:rPr>
               <a:t>String query = buildQueryString(p);</a:t>
             </a:r>
@@ -9402,7 +9402,7 @@
                 <a:solidFill>
                   <a:srgbClr val="E4ECF5"/>
                 </a:solidFill>
-                <a:latin typeface="Consolas"/>
+                <a:latin typeface="Roboto Mono"/>
               </a:rPr>
               <a:t>String url = PAY_URL + "?" + query + "&amp;vnp_SecureHash=" + hmacSHA512(HASH_SECRET, query);</a:t>
             </a:r>
@@ -9417,8 +9417,8 @@
         </p:nvSpPr>
         <p:spPr>
           <a:xfrm>
-            <a:off x="566928" y="5446521"/>
-            <a:ext cx="11057839" cy="1100709"/>
+            <a:off x="566928" y="4828285"/>
+            <a:ext cx="11057839" cy="980694"/>
           </a:xfrm>
           <a:prstGeom prst="rect">
             <a:avLst/>
@@ -9448,7 +9448,7 @@
                 <a:solidFill>
                   <a:srgbClr val="C42B22"/>
                 </a:solidFill>
-                <a:latin typeface="Calibri"/>
+                <a:latin typeface="Arial"/>
               </a:rPr>
               <a:t>Cái bẫy nằm ngay trong code mẫu của chính VNPAY</a:t>
             </a:r>
@@ -9464,7 +9464,7 @@
                 <a:solidFill>
                   <a:srgbClr val="16181D"/>
                 </a:solidFill>
-                <a:latin typeface="Calibri"/>
+                <a:latin typeface="Arial"/>
               </a:rPr>
               <a:t>Họ dùng Etc/GMT+7, mà theo POSIX nó là UTC trừ 7, lệch 14 tiếng.</a:t>
             </a:r>
@@ -9480,7 +9480,7 @@
                 <a:solidFill>
                   <a:srgbClr val="16181D"/>
                 </a:solidFill>
-                <a:latin typeface="Calibri"/>
+                <a:latin typeface="Arial"/>
               </a:rPr>
               <a:t>Giao dịch hết hạn ngay lúc vừa tạo. Mình dùng ZoneId.of("Asia/Ho_Chi_Minh").</a:t>
             </a:r>

</xml_diff>

<commit_message>
Đổi cách nói từ đồ án sang buổi seminar
Co-Authored-By: Claude Opus 5.5 <noreply@anthropic.com>
</commit_message>
<xml_diff>
--- a/VNPAY-seminar.pptx
+++ b/VNPAY-seminar.pptx
@@ -532,7 +532,7 @@
           <a:p>
             <a:r>
               <a:rPr lang="vi-VN" sz="1600" dirty="0"/>
-              <a:t>Chào mọi người, hôm nay mình trình bày về tích hợp VNPAY Sandbox. Buổi này ít lý thuyết, chủ yếu cả lớp code cùng mình. Code chỉ có một file Java, không cần Spring hay Maven.</a:t>
+              <a:t>Chào mọi người, hôm nay mình làm một buổi nhỏ về VNPAY Sandbox. Buổi này làm cho vui thôi, ít lý thuyết, chủ yếu cả lớp code cùng mình. Code chỉ có một file Java, bị lỗi thì cứ giơ tay hỏi nha.</a:t>
             </a:r>
           </a:p>
           <a:p>
@@ -562,7 +562,7 @@
           <a:p>
             <a:r>
               <a:rPr lang="vi-VN" sz="1600" dirty="0"/>
-              <a:t>Đáp: Tự lưu số thẻ là vi phạm chuẩn PCI-DSS, với lại ngân hàng cũng không cấp API cho sinh viên làm đồ án. Nên mới cần cổng trung gian như VNPAY, khách nhập thẻ trên trang của VNPAY.</a:t>
+              <a:t>Đáp: Tự lưu số thẻ là vi phạm chuẩn PCI-DSS, với lại ngân hàng cũng không cấp API cho mình tự gọi. Nên mới cần cổng trung gian như VNPAY, khách nhập thẻ trên trang của VNPAY.</a:t>
             </a:r>
           </a:p>
           <a:p>
@@ -1321,7 +1321,7 @@
           <a:p>
             <a:r>
               <a:rPr lang="vi-VN" sz="1600" dirty="0"/>
-              <a:t>Đáp: Deploy lên server có IP public, hoặc dùng Cloudflare Tunnel. Nhưng làm đồ án thì ngrok là nhanh nhất.</a:t>
+              <a:t>Đáp: Deploy lên server có IP public, hoặc dùng Cloudflare Tunnel. Nhưng để thử nhanh như hôm nay thì ngrok là tiện nhất.</a:t>
             </a:r>
           </a:p>
           <a:p>
@@ -2500,7 +2500,7 @@
           <a:p>
             <a:r>
               <a:rPr lang="vi-VN" sz="1600" b="1" dirty="0"/>
-              <a:t>Hỏi: Làm tới đây rồi thì đồ án làm gì tiếp?</a:t>
+              <a:t>Hỏi: Muốn làm thành web bán hàng thật thì thêm gì nữa?</a:t>
             </a:r>
           </a:p>
           <a:p>
@@ -2632,7 +2632,7 @@
           <a:p>
             <a:r>
               <a:rPr lang="vi-VN" sz="1600" b="1" dirty="0"/>
-              <a:t>Hỏi: Trong đồ án nên gọi querydr lúc nào?</a:t>
+              <a:t>Hỏi: Web thật thì nên gọi querydr lúc nào?</a:t>
             </a:r>
           </a:p>
           <a:p>
@@ -2854,7 +2854,7 @@
           <a:p>
             <a:r>
               <a:rPr lang="vi-VN" sz="1600" dirty="0"/>
-              <a:t>Đây là mấy điều cần nhớ khi đưa vào đồ án, quan trọng nhất là cái đầu: chỉ cập nhật trạng thái đơn từ IPN hoặc querydr.</a:t>
+              <a:t>Đây là mấy điều nên nhớ nếu sau này mọi người tự tích hợp VNPAY, quan trọng nhất là cái đầu: chỉ cập nhật trạng thái đơn từ IPN hoặc querydr.</a:t>
             </a:r>
           </a:p>
           <a:p>
@@ -3001,7 +3001,7 @@
           <a:p>
             <a:r>
               <a:rPr lang="vi-VN" sz="1600" dirty="0"/>
-              <a:t>Phần của mình tới đây là hết. Mọi người có câu hỏi gì thì hỏi nha, bạn nào còn bị lỗi thì mở ShopDone.java trên Drive ra so.</a:t>
+              <a:t>Phần của mình tới đây là hết, cảm ơn mọi người đã code cùng mình. Ai có câu hỏi gì thì hỏi nha, bạn nào còn bị lỗi thì mở ShopDone.java trên Drive ra so.</a:t>
             </a:r>
           </a:p>
           <a:p>
@@ -20592,7 +20592,7 @@
         <p:spPr>
           <a:xfrm>
             <a:off x="660380" y="643829"/>
-            <a:ext cx="3662081" cy="426750"/>
+            <a:ext cx="7023324" cy="426750"/>
           </a:xfrm>
           <a:prstGeom prst="rect">
             <a:avLst/>
@@ -20616,7 +20616,7 @@
                 <a:ea typeface="Arial" pitchFamily="34" charset="-122"/>
                 <a:cs typeface="Arial" pitchFamily="34" charset="-120"/>
               </a:rPr>
-              <a:t>Lưu ý khi làm đồ án</a:t>
+              <a:t>Mấy điều nên nhớ khi tích hợp VNPAY</a:t>
             </a:r>
             <a:endParaRPr lang="en-US" sz="3000" dirty="0"/>
           </a:p>

</xml_diff>